<commit_message>
Remove old presentation versions
</commit_message>
<xml_diff>
--- a/choke_controller_presentation.pptx
+++ b/choke_controller_presentation.pptx
@@ -5,17 +5,17 @@
     <p:sldMasterId id="2147483648" r:id="rId1"/>
   </p:sldMasterIdLst>
   <p:notesMasterIdLst>
-    <p:notesMasterId r:id="rId9"/>
+    <p:notesMasterId r:id="rId8"/>
   </p:notesMasterIdLst>
   <p:sldIdLst>
-    <p:sldId id="298" r:id="rId3"/>
-    <p:sldId id="281" r:id="rId4"/>
-    <p:sldId id="290" r:id="rId5"/>
-    <p:sldId id="293" r:id="rId6"/>
-    <p:sldId id="299" r:id="rId7"/>
-    <p:sldId id="296" r:id="rId8"/>
+    <p:sldId id="298" r:id="rId2"/>
+    <p:sldId id="281" r:id="rId3"/>
+    <p:sldId id="290" r:id="rId4"/>
+    <p:sldId id="293" r:id="rId5"/>
+    <p:sldId id="299" r:id="rId6"/>
+    <p:sldId id="296" r:id="rId7"/>
   </p:sldIdLst>
-  <p:sldSz cx="12188952" cy="6858000"/>
+  <p:sldSz cx="12188825" cy="6858000"/>
   <p:notesSz cx="6858000" cy="9144000"/>
   <p:defaultTextStyle>
     <a:defPPr>
@@ -261,7 +261,7 @@
             <a:fld id="{C4D5ADD5-2BBC-4A94-8F86-D9013941F742}" type="datetimeFigureOut">
               <a:rPr lang="en-US"/>
               <a:pPr/>
-              <a:t>7/24/2026</a:t>
+              <a:t>7/25/2026</a:t>
             </a:fld>
             <a:endParaRPr lang="en-US"/>
           </a:p>
@@ -598,6 +598,244 @@
       </p:grpSpPr>
       <p:sp>
         <p:nvSpPr>
+          <p:cNvPr id="16385" name="Slide Image Placeholder 1"/>
+          <p:cNvSpPr>
+            <a:spLocks noGrp="1" noRot="1" noChangeAspect="1"/>
+          </p:cNvSpPr>
+          <p:nvPr>
+            <p:ph type="sldImg"/>
+          </p:nvPr>
+        </p:nvSpPr>
+        <p:spPr bwMode="auto">
+          <a:xfrm>
+            <a:off x="381000" y="685800"/>
+            <a:ext cx="6096000" cy="3429000"/>
+          </a:xfrm>
+          <a:noFill/>
+          <a:ln>
+            <a:solidFill>
+              <a:srgbClr val="000000"/>
+            </a:solidFill>
+            <a:miter lim="800000"/>
+            <a:headEnd/>
+            <a:tailEnd/>
+          </a:ln>
+        </p:spPr>
+      </p:sp>
+      <p:sp>
+        <p:nvSpPr>
+          <p:cNvPr id="16386" name="Notes Placeholder 2"/>
+          <p:cNvSpPr>
+            <a:spLocks noGrp="1"/>
+          </p:cNvSpPr>
+          <p:nvPr>
+            <p:ph type="body" idx="1"/>
+          </p:nvPr>
+        </p:nvSpPr>
+        <p:spPr bwMode="auto">
+          <a:noFill/>
+        </p:spPr>
+        <p:txBody>
+          <a:bodyPr wrap="square" numCol="1" anchor="t" anchorCtr="0" compatLnSpc="1">
+            <a:prstTxWarp prst="textNoShape">
+              <a:avLst/>
+            </a:prstTxWarp>
+          </a:bodyPr>
+          <a:lstStyle/>
+          <a:p>
+            <a:pPr eaLnBrk="1" hangingPunct="1">
+              <a:spcBef>
+                <a:spcPct val="0"/>
+              </a:spcBef>
+            </a:pPr>
+            <a:endParaRPr lang="en-US">
+              <a:ea typeface="ＭＳ Ｐゴシック" pitchFamily="1" charset="-128"/>
+            </a:endParaRPr>
+          </a:p>
+        </p:txBody>
+      </p:sp>
+      <p:sp>
+        <p:nvSpPr>
+          <p:cNvPr id="16387" name="Slide Number Placeholder 3"/>
+          <p:cNvSpPr>
+            <a:spLocks noGrp="1"/>
+          </p:cNvSpPr>
+          <p:nvPr>
+            <p:ph type="sldNum" sz="quarter" idx="5"/>
+          </p:nvPr>
+        </p:nvSpPr>
+        <p:spPr bwMode="auto">
+          <a:noFill/>
+          <a:ln>
+            <a:miter lim="800000"/>
+            <a:headEnd/>
+            <a:tailEnd/>
+          </a:ln>
+        </p:spPr>
+        <p:txBody>
+          <a:bodyPr/>
+          <a:lstStyle/>
+          <a:p>
+            <a:fld id="{65F62A7E-A2F8-438F-9CF8-47DE63F471B4}" type="slidenum">
+              <a:rPr lang="en-US"/>
+              <a:pPr/>
+              <a:t>2</a:t>
+            </a:fld>
+            <a:endParaRPr lang="en-US"/>
+          </a:p>
+        </p:txBody>
+      </p:sp>
+    </p:spTree>
+    <p:extLst>
+      <p:ext uri="{BB962C8B-B14F-4D97-AF65-F5344CB8AC3E}">
+        <p14:creationId xmlns:p14="http://schemas.microsoft.com/office/powerpoint/2010/main" val="2904073229"/>
+      </p:ext>
+    </p:extLst>
+  </p:cSld>
+  <p:clrMapOvr>
+    <a:masterClrMapping/>
+  </p:clrMapOvr>
+</p:notes>
+</file>
+
+<file path=ppt/notesSlides/notesSlide2.xml><?xml version="1.0" encoding="utf-8"?>
+<p:notes xmlns:a="http://schemas.openxmlformats.org/drawingml/2006/main" xmlns:r="http://schemas.openxmlformats.org/officeDocument/2006/relationships" xmlns:p="http://schemas.openxmlformats.org/presentationml/2006/main">
+  <p:cSld>
+    <p:spTree>
+      <p:nvGrpSpPr>
+        <p:cNvPr id="1" name=""/>
+        <p:cNvGrpSpPr/>
+        <p:nvPr/>
+      </p:nvGrpSpPr>
+      <p:grpSpPr>
+        <a:xfrm>
+          <a:off x="0" y="0"/>
+          <a:ext cx="0" cy="0"/>
+          <a:chOff x="0" y="0"/>
+          <a:chExt cx="0" cy="0"/>
+        </a:xfrm>
+      </p:grpSpPr>
+      <p:sp>
+        <p:nvSpPr>
+          <p:cNvPr id="18433" name="Slide Image Placeholder 1"/>
+          <p:cNvSpPr>
+            <a:spLocks noGrp="1" noRot="1" noChangeAspect="1"/>
+          </p:cNvSpPr>
+          <p:nvPr>
+            <p:ph type="sldImg"/>
+          </p:nvPr>
+        </p:nvSpPr>
+        <p:spPr bwMode="auto">
+          <a:xfrm>
+            <a:off x="381000" y="685800"/>
+            <a:ext cx="6096000" cy="3429000"/>
+          </a:xfrm>
+          <a:noFill/>
+          <a:ln>
+            <a:solidFill>
+              <a:srgbClr val="000000"/>
+            </a:solidFill>
+            <a:miter lim="800000"/>
+            <a:headEnd/>
+            <a:tailEnd/>
+          </a:ln>
+        </p:spPr>
+      </p:sp>
+      <p:sp>
+        <p:nvSpPr>
+          <p:cNvPr id="18434" name="Notes Placeholder 2"/>
+          <p:cNvSpPr>
+            <a:spLocks noGrp="1"/>
+          </p:cNvSpPr>
+          <p:nvPr>
+            <p:ph type="body" idx="1"/>
+          </p:nvPr>
+        </p:nvSpPr>
+        <p:spPr bwMode="auto">
+          <a:noFill/>
+        </p:spPr>
+        <p:txBody>
+          <a:bodyPr wrap="square" numCol="1" anchor="t" anchorCtr="0" compatLnSpc="1">
+            <a:prstTxWarp prst="textNoShape">
+              <a:avLst/>
+            </a:prstTxWarp>
+          </a:bodyPr>
+          <a:lstStyle/>
+          <a:p>
+            <a:pPr eaLnBrk="1" hangingPunct="1">
+              <a:spcBef>
+                <a:spcPct val="0"/>
+              </a:spcBef>
+            </a:pPr>
+            <a:endParaRPr lang="en-US">
+              <a:ea typeface="ＭＳ Ｐゴシック" pitchFamily="1" charset="-128"/>
+            </a:endParaRPr>
+          </a:p>
+        </p:txBody>
+      </p:sp>
+      <p:sp>
+        <p:nvSpPr>
+          <p:cNvPr id="18435" name="Slide Number Placeholder 3"/>
+          <p:cNvSpPr>
+            <a:spLocks noGrp="1"/>
+          </p:cNvSpPr>
+          <p:nvPr>
+            <p:ph type="sldNum" sz="quarter" idx="5"/>
+          </p:nvPr>
+        </p:nvSpPr>
+        <p:spPr bwMode="auto">
+          <a:noFill/>
+          <a:ln>
+            <a:miter lim="800000"/>
+            <a:headEnd/>
+            <a:tailEnd/>
+          </a:ln>
+        </p:spPr>
+        <p:txBody>
+          <a:bodyPr/>
+          <a:lstStyle/>
+          <a:p>
+            <a:fld id="{0CA7B74D-3791-4AC6-8451-F10DBCCCDD9A}" type="slidenum">
+              <a:rPr lang="en-US"/>
+              <a:pPr/>
+              <a:t>3</a:t>
+            </a:fld>
+            <a:endParaRPr lang="en-US"/>
+          </a:p>
+        </p:txBody>
+      </p:sp>
+    </p:spTree>
+    <p:extLst>
+      <p:ext uri="{BB962C8B-B14F-4D97-AF65-F5344CB8AC3E}">
+        <p14:creationId xmlns:p14="http://schemas.microsoft.com/office/powerpoint/2010/main" val="2335206292"/>
+      </p:ext>
+    </p:extLst>
+  </p:cSld>
+  <p:clrMapOvr>
+    <a:masterClrMapping/>
+  </p:clrMapOvr>
+</p:notes>
+</file>
+
+<file path=ppt/notesSlides/notesSlide3.xml><?xml version="1.0" encoding="utf-8"?>
+<p:notes xmlns:a="http://schemas.openxmlformats.org/drawingml/2006/main" xmlns:r="http://schemas.openxmlformats.org/officeDocument/2006/relationships" xmlns:p="http://schemas.openxmlformats.org/presentationml/2006/main">
+  <p:cSld>
+    <p:spTree>
+      <p:nvGrpSpPr>
+        <p:cNvPr id="1" name=""/>
+        <p:cNvGrpSpPr/>
+        <p:nvPr/>
+      </p:nvGrpSpPr>
+      <p:grpSpPr>
+        <a:xfrm>
+          <a:off x="0" y="0"/>
+          <a:ext cx="0" cy="0"/>
+          <a:chOff x="0" y="0"/>
+          <a:chExt cx="0" cy="0"/>
+        </a:xfrm>
+      </p:grpSpPr>
+      <p:sp>
+        <p:nvSpPr>
           <p:cNvPr id="18433" name="Slide Image Placeholder 1"/>
           <p:cNvSpPr>
             <a:spLocks noGrp="1" noRot="1" noChangeAspect="1"/>
@@ -725,7 +963,7 @@
                 <a:tabLst/>
                 <a:defRPr/>
               </a:pPr>
-              <a:t>1</a:t>
+              <a:t>4</a:t>
             </a:fld>
             <a:endParaRPr kumimoji="0" lang="en-US" sz="1200" b="0" i="0" u="none" strike="noStrike" kern="1200" cap="none" spc="0" normalizeH="0" baseline="0" noProof="0">
               <a:ln>
@@ -747,7 +985,7 @@
     </p:spTree>
     <p:extLst>
       <p:ext uri="{BB962C8B-B14F-4D97-AF65-F5344CB8AC3E}">
-        <p14:creationId xmlns:p14="http://schemas.microsoft.com/office/powerpoint/2010/main" val="3783576877"/>
+        <p14:creationId xmlns:p14="http://schemas.microsoft.com/office/powerpoint/2010/main" val="3773505461"/>
       </p:ext>
     </p:extLst>
   </p:cSld>
@@ -757,12 +995,18 @@
 </p:notes>
 </file>
 
-<file path=ppt/notesSlides/notesSlide2.xml><?xml version="1.0" encoding="utf-8"?>
+<file path=ppt/notesSlides/notesSlide4.xml><?xml version="1.0" encoding="utf-8"?>
 <p:notes xmlns:a="http://schemas.openxmlformats.org/drawingml/2006/main" xmlns:r="http://schemas.openxmlformats.org/officeDocument/2006/relationships" xmlns:p="http://schemas.openxmlformats.org/presentationml/2006/main">
   <p:cSld>
     <p:spTree>
       <p:nvGrpSpPr>
-        <p:cNvPr id="1" name=""/>
+        <p:cNvPr id="1" name="">
+          <a:extLst>
+            <a:ext uri="{FF2B5EF4-FFF2-40B4-BE49-F238E27FC236}">
+              <a16:creationId xmlns:a16="http://schemas.microsoft.com/office/drawing/2014/main" id="{9949F277-D966-5891-8E8E-FE1852E6B425}"/>
+            </a:ext>
+          </a:extLst>
+        </p:cNvPr>
         <p:cNvGrpSpPr/>
         <p:nvPr/>
       </p:nvGrpSpPr>
@@ -776,7 +1020,13 @@
       </p:grpSpPr>
       <p:sp>
         <p:nvSpPr>
-          <p:cNvPr id="16385" name="Slide Image Placeholder 1"/>
+          <p:cNvPr id="18433" name="Slide Image Placeholder 1">
+            <a:extLst>
+              <a:ext uri="{FF2B5EF4-FFF2-40B4-BE49-F238E27FC236}">
+                <a16:creationId xmlns:a16="http://schemas.microsoft.com/office/drawing/2014/main" id="{63166A99-EAE2-2E28-993F-D5871297B24D}"/>
+              </a:ext>
+            </a:extLst>
+          </p:cNvPr>
           <p:cNvSpPr>
             <a:spLocks noGrp="1" noRot="1" noChangeAspect="1"/>
           </p:cNvSpPr>
@@ -802,7 +1052,13 @@
       </p:sp>
       <p:sp>
         <p:nvSpPr>
-          <p:cNvPr id="16386" name="Notes Placeholder 2"/>
+          <p:cNvPr id="18434" name="Notes Placeholder 2">
+            <a:extLst>
+              <a:ext uri="{FF2B5EF4-FFF2-40B4-BE49-F238E27FC236}">
+                <a16:creationId xmlns:a16="http://schemas.microsoft.com/office/drawing/2014/main" id="{4ED88F3D-7791-59C8-716F-0AAD4C669A9A}"/>
+              </a:ext>
+            </a:extLst>
+          </p:cNvPr>
           <p:cNvSpPr>
             <a:spLocks noGrp="1"/>
           </p:cNvSpPr>
@@ -834,245 +1090,13 @@
       </p:sp>
       <p:sp>
         <p:nvSpPr>
-          <p:cNvPr id="16387" name="Slide Number Placeholder 3"/>
-          <p:cNvSpPr>
-            <a:spLocks noGrp="1"/>
-          </p:cNvSpPr>
-          <p:nvPr>
-            <p:ph type="sldNum" sz="quarter" idx="5"/>
-          </p:nvPr>
-        </p:nvSpPr>
-        <p:spPr bwMode="auto">
-          <a:noFill/>
-          <a:ln>
-            <a:miter lim="800000"/>
-            <a:headEnd/>
-            <a:tailEnd/>
-          </a:ln>
-        </p:spPr>
-        <p:txBody>
-          <a:bodyPr/>
-          <a:lstStyle/>
-          <a:p>
-            <a:fld id="{65F62A7E-A2F8-438F-9CF8-47DE63F471B4}" type="slidenum">
-              <a:rPr lang="en-US"/>
-              <a:pPr/>
-              <a:t>3</a:t>
-            </a:fld>
-            <a:endParaRPr lang="en-US"/>
-          </a:p>
-        </p:txBody>
-      </p:sp>
-    </p:spTree>
-    <p:extLst>
-      <p:ext uri="{BB962C8B-B14F-4D97-AF65-F5344CB8AC3E}">
-        <p14:creationId xmlns:p14="http://schemas.microsoft.com/office/powerpoint/2010/main" val="2904073229"/>
-      </p:ext>
-    </p:extLst>
-  </p:cSld>
-  <p:clrMapOvr>
-    <a:masterClrMapping/>
-  </p:clrMapOvr>
-</p:notes>
-</file>
-
-<file path=ppt/notesSlides/notesSlide3.xml><?xml version="1.0" encoding="utf-8"?>
-<p:notes xmlns:a="http://schemas.openxmlformats.org/drawingml/2006/main" xmlns:r="http://schemas.openxmlformats.org/officeDocument/2006/relationships" xmlns:p="http://schemas.openxmlformats.org/presentationml/2006/main">
-  <p:cSld>
-    <p:spTree>
-      <p:nvGrpSpPr>
-        <p:cNvPr id="1" name=""/>
-        <p:cNvGrpSpPr/>
-        <p:nvPr/>
-      </p:nvGrpSpPr>
-      <p:grpSpPr>
-        <a:xfrm>
-          <a:off x="0" y="0"/>
-          <a:ext cx="0" cy="0"/>
-          <a:chOff x="0" y="0"/>
-          <a:chExt cx="0" cy="0"/>
-        </a:xfrm>
-      </p:grpSpPr>
-      <p:sp>
-        <p:nvSpPr>
-          <p:cNvPr id="18433" name="Slide Image Placeholder 1"/>
-          <p:cNvSpPr>
-            <a:spLocks noGrp="1" noRot="1" noChangeAspect="1"/>
-          </p:cNvSpPr>
-          <p:nvPr>
-            <p:ph type="sldImg"/>
-          </p:nvPr>
-        </p:nvSpPr>
-        <p:spPr bwMode="auto">
-          <a:xfrm>
-            <a:off x="381000" y="685800"/>
-            <a:ext cx="6096000" cy="3429000"/>
-          </a:xfrm>
-          <a:noFill/>
-          <a:ln>
-            <a:solidFill>
-              <a:srgbClr val="000000"/>
-            </a:solidFill>
-            <a:miter lim="800000"/>
-            <a:headEnd/>
-            <a:tailEnd/>
-          </a:ln>
-        </p:spPr>
-      </p:sp>
-      <p:sp>
-        <p:nvSpPr>
-          <p:cNvPr id="18434" name="Notes Placeholder 2"/>
-          <p:cNvSpPr>
-            <a:spLocks noGrp="1"/>
-          </p:cNvSpPr>
-          <p:nvPr>
-            <p:ph type="body" idx="1"/>
-          </p:nvPr>
-        </p:nvSpPr>
-        <p:spPr bwMode="auto">
-          <a:noFill/>
-        </p:spPr>
-        <p:txBody>
-          <a:bodyPr wrap="square" numCol="1" anchor="t" anchorCtr="0" compatLnSpc="1">
-            <a:prstTxWarp prst="textNoShape">
-              <a:avLst/>
-            </a:prstTxWarp>
-          </a:bodyPr>
-          <a:lstStyle/>
-          <a:p>
-            <a:pPr eaLnBrk="1" hangingPunct="1">
-              <a:spcBef>
-                <a:spcPct val="0"/>
-              </a:spcBef>
-            </a:pPr>
-            <a:endParaRPr lang="en-US">
-              <a:ea typeface="ＭＳ Ｐゴシック" pitchFamily="1" charset="-128"/>
-            </a:endParaRPr>
-          </a:p>
-        </p:txBody>
-      </p:sp>
-      <p:sp>
-        <p:nvSpPr>
-          <p:cNvPr id="18435" name="Slide Number Placeholder 3"/>
-          <p:cNvSpPr>
-            <a:spLocks noGrp="1"/>
-          </p:cNvSpPr>
-          <p:nvPr>
-            <p:ph type="sldNum" sz="quarter" idx="5"/>
-          </p:nvPr>
-        </p:nvSpPr>
-        <p:spPr bwMode="auto">
-          <a:noFill/>
-          <a:ln>
-            <a:miter lim="800000"/>
-            <a:headEnd/>
-            <a:tailEnd/>
-          </a:ln>
-        </p:spPr>
-        <p:txBody>
-          <a:bodyPr/>
-          <a:lstStyle/>
-          <a:p>
-            <a:fld id="{0CA7B74D-3791-4AC6-8451-F10DBCCCDD9A}" type="slidenum">
-              <a:rPr lang="en-US"/>
-              <a:pPr/>
-              <a:t>4</a:t>
-            </a:fld>
-            <a:endParaRPr lang="en-US"/>
-          </a:p>
-        </p:txBody>
-      </p:sp>
-    </p:spTree>
-    <p:extLst>
-      <p:ext uri="{BB962C8B-B14F-4D97-AF65-F5344CB8AC3E}">
-        <p14:creationId xmlns:p14="http://schemas.microsoft.com/office/powerpoint/2010/main" val="2335206292"/>
-      </p:ext>
-    </p:extLst>
-  </p:cSld>
-  <p:clrMapOvr>
-    <a:masterClrMapping/>
-  </p:clrMapOvr>
-</p:notes>
-</file>
-
-<file path=ppt/notesSlides/notesSlide4.xml><?xml version="1.0" encoding="utf-8"?>
-<p:notes xmlns:a="http://schemas.openxmlformats.org/drawingml/2006/main" xmlns:r="http://schemas.openxmlformats.org/officeDocument/2006/relationships" xmlns:p="http://schemas.openxmlformats.org/presentationml/2006/main">
-  <p:cSld>
-    <p:spTree>
-      <p:nvGrpSpPr>
-        <p:cNvPr id="1" name=""/>
-        <p:cNvGrpSpPr/>
-        <p:nvPr/>
-      </p:nvGrpSpPr>
-      <p:grpSpPr>
-        <a:xfrm>
-          <a:off x="0" y="0"/>
-          <a:ext cx="0" cy="0"/>
-          <a:chOff x="0" y="0"/>
-          <a:chExt cx="0" cy="0"/>
-        </a:xfrm>
-      </p:grpSpPr>
-      <p:sp>
-        <p:nvSpPr>
-          <p:cNvPr id="18433" name="Slide Image Placeholder 1"/>
-          <p:cNvSpPr>
-            <a:spLocks noGrp="1" noRot="1" noChangeAspect="1"/>
-          </p:cNvSpPr>
-          <p:nvPr>
-            <p:ph type="sldImg"/>
-          </p:nvPr>
-        </p:nvSpPr>
-        <p:spPr bwMode="auto">
-          <a:xfrm>
-            <a:off x="381000" y="685800"/>
-            <a:ext cx="6096000" cy="3429000"/>
-          </a:xfrm>
-          <a:noFill/>
-          <a:ln>
-            <a:solidFill>
-              <a:srgbClr val="000000"/>
-            </a:solidFill>
-            <a:miter lim="800000"/>
-            <a:headEnd/>
-            <a:tailEnd/>
-          </a:ln>
-        </p:spPr>
-      </p:sp>
-      <p:sp>
-        <p:nvSpPr>
-          <p:cNvPr id="18434" name="Notes Placeholder 2"/>
-          <p:cNvSpPr>
-            <a:spLocks noGrp="1"/>
-          </p:cNvSpPr>
-          <p:nvPr>
-            <p:ph type="body" idx="1"/>
-          </p:nvPr>
-        </p:nvSpPr>
-        <p:spPr bwMode="auto">
-          <a:noFill/>
-        </p:spPr>
-        <p:txBody>
-          <a:bodyPr wrap="square" numCol="1" anchor="t" anchorCtr="0" compatLnSpc="1">
-            <a:prstTxWarp prst="textNoShape">
-              <a:avLst/>
-            </a:prstTxWarp>
-          </a:bodyPr>
-          <a:lstStyle/>
-          <a:p>
-            <a:pPr eaLnBrk="1" hangingPunct="1">
-              <a:spcBef>
-                <a:spcPct val="0"/>
-              </a:spcBef>
-            </a:pPr>
-            <a:endParaRPr lang="en-US">
-              <a:ea typeface="ＭＳ Ｐゴシック" pitchFamily="1" charset="-128"/>
-            </a:endParaRPr>
-          </a:p>
-        </p:txBody>
-      </p:sp>
-      <p:sp>
-        <p:nvSpPr>
-          <p:cNvPr id="18435" name="Slide Number Placeholder 3"/>
+          <p:cNvPr id="18435" name="Slide Number Placeholder 3">
+            <a:extLst>
+              <a:ext uri="{FF2B5EF4-FFF2-40B4-BE49-F238E27FC236}">
+                <a16:creationId xmlns:a16="http://schemas.microsoft.com/office/drawing/2014/main" id="{CC82298B-112C-33CB-5F98-D6F1C4A4C6DE}"/>
+              </a:ext>
+            </a:extLst>
+          </p:cNvPr>
           <p:cNvSpPr>
             <a:spLocks noGrp="1"/>
           </p:cNvSpPr>
@@ -1163,7 +1187,7 @@
     </p:spTree>
     <p:extLst>
       <p:ext uri="{BB962C8B-B14F-4D97-AF65-F5344CB8AC3E}">
-        <p14:creationId xmlns:p14="http://schemas.microsoft.com/office/powerpoint/2010/main" val="3773505461"/>
+        <p14:creationId xmlns:p14="http://schemas.microsoft.com/office/powerpoint/2010/main" val="4173051335"/>
       </p:ext>
     </p:extLst>
   </p:cSld>
@@ -1178,13 +1202,7 @@
   <p:cSld>
     <p:spTree>
       <p:nvGrpSpPr>
-        <p:cNvPr id="1" name="">
-          <a:extLst>
-            <a:ext uri="{FF2B5EF4-FFF2-40B4-BE49-F238E27FC236}">
-              <a16:creationId xmlns:a16="http://schemas.microsoft.com/office/drawing/2014/main" id="{9949F277-D966-5891-8E8E-FE1852E6B425}"/>
-            </a:ext>
-          </a:extLst>
-        </p:cNvPr>
+        <p:cNvPr id="1" name=""/>
         <p:cNvGrpSpPr/>
         <p:nvPr/>
       </p:nvGrpSpPr>
@@ -1198,13 +1216,7 @@
       </p:grpSpPr>
       <p:sp>
         <p:nvSpPr>
-          <p:cNvPr id="18433" name="Slide Image Placeholder 1">
-            <a:extLst>
-              <a:ext uri="{FF2B5EF4-FFF2-40B4-BE49-F238E27FC236}">
-                <a16:creationId xmlns:a16="http://schemas.microsoft.com/office/drawing/2014/main" id="{63166A99-EAE2-2E28-993F-D5871297B24D}"/>
-              </a:ext>
-            </a:extLst>
-          </p:cNvPr>
+          <p:cNvPr id="18433" name="Slide Image Placeholder 1"/>
           <p:cNvSpPr>
             <a:spLocks noGrp="1" noRot="1" noChangeAspect="1"/>
           </p:cNvSpPr>
@@ -1230,13 +1242,7 @@
       </p:sp>
       <p:sp>
         <p:nvSpPr>
-          <p:cNvPr id="18434" name="Notes Placeholder 2">
-            <a:extLst>
-              <a:ext uri="{FF2B5EF4-FFF2-40B4-BE49-F238E27FC236}">
-                <a16:creationId xmlns:a16="http://schemas.microsoft.com/office/drawing/2014/main" id="{4ED88F3D-7791-59C8-716F-0AAD4C669A9A}"/>
-              </a:ext>
-            </a:extLst>
-          </p:cNvPr>
+          <p:cNvPr id="18434" name="Notes Placeholder 2"/>
           <p:cNvSpPr>
             <a:spLocks noGrp="1"/>
           </p:cNvSpPr>
@@ -1268,13 +1274,7 @@
       </p:sp>
       <p:sp>
         <p:nvSpPr>
-          <p:cNvPr id="18435" name="Slide Number Placeholder 3">
-            <a:extLst>
-              <a:ext uri="{FF2B5EF4-FFF2-40B4-BE49-F238E27FC236}">
-                <a16:creationId xmlns:a16="http://schemas.microsoft.com/office/drawing/2014/main" id="{CC82298B-112C-33CB-5F98-D6F1C4A4C6DE}"/>
-              </a:ext>
-            </a:extLst>
-          </p:cNvPr>
+          <p:cNvPr id="18435" name="Slide Number Placeholder 3"/>
           <p:cNvSpPr>
             <a:spLocks noGrp="1"/>
           </p:cNvSpPr>
@@ -1365,184 +1365,6 @@
     </p:spTree>
     <p:extLst>
       <p:ext uri="{BB962C8B-B14F-4D97-AF65-F5344CB8AC3E}">
-        <p14:creationId xmlns:p14="http://schemas.microsoft.com/office/powerpoint/2010/main" val="4173051335"/>
-      </p:ext>
-    </p:extLst>
-  </p:cSld>
-  <p:clrMapOvr>
-    <a:masterClrMapping/>
-  </p:clrMapOvr>
-</p:notes>
-</file>
-
-<file path=ppt/notesSlides/notesSlide6.xml><?xml version="1.0" encoding="utf-8"?>
-<p:notes xmlns:a="http://schemas.openxmlformats.org/drawingml/2006/main" xmlns:r="http://schemas.openxmlformats.org/officeDocument/2006/relationships" xmlns:p="http://schemas.openxmlformats.org/presentationml/2006/main">
-  <p:cSld>
-    <p:spTree>
-      <p:nvGrpSpPr>
-        <p:cNvPr id="1" name=""/>
-        <p:cNvGrpSpPr/>
-        <p:nvPr/>
-      </p:nvGrpSpPr>
-      <p:grpSpPr>
-        <a:xfrm>
-          <a:off x="0" y="0"/>
-          <a:ext cx="0" cy="0"/>
-          <a:chOff x="0" y="0"/>
-          <a:chExt cx="0" cy="0"/>
-        </a:xfrm>
-      </p:grpSpPr>
-      <p:sp>
-        <p:nvSpPr>
-          <p:cNvPr id="18433" name="Slide Image Placeholder 1"/>
-          <p:cNvSpPr>
-            <a:spLocks noGrp="1" noRot="1" noChangeAspect="1"/>
-          </p:cNvSpPr>
-          <p:nvPr>
-            <p:ph type="sldImg"/>
-          </p:nvPr>
-        </p:nvSpPr>
-        <p:spPr bwMode="auto">
-          <a:xfrm>
-            <a:off x="381000" y="685800"/>
-            <a:ext cx="6096000" cy="3429000"/>
-          </a:xfrm>
-          <a:noFill/>
-          <a:ln>
-            <a:solidFill>
-              <a:srgbClr val="000000"/>
-            </a:solidFill>
-            <a:miter lim="800000"/>
-            <a:headEnd/>
-            <a:tailEnd/>
-          </a:ln>
-        </p:spPr>
-      </p:sp>
-      <p:sp>
-        <p:nvSpPr>
-          <p:cNvPr id="18434" name="Notes Placeholder 2"/>
-          <p:cNvSpPr>
-            <a:spLocks noGrp="1"/>
-          </p:cNvSpPr>
-          <p:nvPr>
-            <p:ph type="body" idx="1"/>
-          </p:nvPr>
-        </p:nvSpPr>
-        <p:spPr bwMode="auto">
-          <a:noFill/>
-        </p:spPr>
-        <p:txBody>
-          <a:bodyPr wrap="square" numCol="1" anchor="t" anchorCtr="0" compatLnSpc="1">
-            <a:prstTxWarp prst="textNoShape">
-              <a:avLst/>
-            </a:prstTxWarp>
-          </a:bodyPr>
-          <a:lstStyle/>
-          <a:p>
-            <a:pPr eaLnBrk="1" hangingPunct="1">
-              <a:spcBef>
-                <a:spcPct val="0"/>
-              </a:spcBef>
-            </a:pPr>
-            <a:endParaRPr lang="en-US">
-              <a:ea typeface="ＭＳ Ｐゴシック" pitchFamily="1" charset="-128"/>
-            </a:endParaRPr>
-          </a:p>
-        </p:txBody>
-      </p:sp>
-      <p:sp>
-        <p:nvSpPr>
-          <p:cNvPr id="18435" name="Slide Number Placeholder 3"/>
-          <p:cNvSpPr>
-            <a:spLocks noGrp="1"/>
-          </p:cNvSpPr>
-          <p:nvPr>
-            <p:ph type="sldNum" sz="quarter" idx="5"/>
-          </p:nvPr>
-        </p:nvSpPr>
-        <p:spPr bwMode="auto">
-          <a:noFill/>
-          <a:ln>
-            <a:miter lim="800000"/>
-            <a:headEnd/>
-            <a:tailEnd/>
-          </a:ln>
-        </p:spPr>
-        <p:txBody>
-          <a:bodyPr/>
-          <a:lstStyle/>
-          <a:p>
-            <a:pPr marL="0" marR="0" lvl="0" indent="0" algn="r" defTabSz="457200" rtl="0" eaLnBrk="1" fontAlgn="base" latinLnBrk="0" hangingPunct="1">
-              <a:lnSpc>
-                <a:spcPct val="100000"/>
-              </a:lnSpc>
-              <a:spcBef>
-                <a:spcPct val="0"/>
-              </a:spcBef>
-              <a:spcAft>
-                <a:spcPct val="0"/>
-              </a:spcAft>
-              <a:buClrTx/>
-              <a:buSzTx/>
-              <a:buFontTx/>
-              <a:buNone/>
-              <a:tabLst/>
-              <a:defRPr/>
-            </a:pPr>
-            <a:fld id="{0CA7B74D-3791-4AC6-8451-F10DBCCCDD9A}" type="slidenum">
-              <a:rPr kumimoji="0" lang="en-US" sz="1200" b="0" i="0" u="none" strike="noStrike" kern="1200" cap="none" spc="0" normalizeH="0" baseline="0" noProof="0">
-                <a:ln>
-                  <a:noFill/>
-                </a:ln>
-                <a:solidFill>
-                  <a:prstClr val="black"/>
-                </a:solidFill>
-                <a:effectLst/>
-                <a:uLnTx/>
-                <a:uFillTx/>
-                <a:latin typeface="Calibri" pitchFamily="34" charset="0"/>
-                <a:ea typeface="ＭＳ Ｐゴシック" pitchFamily="1" charset="-128"/>
-                <a:cs typeface="+mn-cs"/>
-              </a:rPr>
-              <a:pPr marL="0" marR="0" lvl="0" indent="0" algn="r" defTabSz="457200" rtl="0" eaLnBrk="1" fontAlgn="base" latinLnBrk="0" hangingPunct="1">
-                <a:lnSpc>
-                  <a:spcPct val="100000"/>
-                </a:lnSpc>
-                <a:spcBef>
-                  <a:spcPct val="0"/>
-                </a:spcBef>
-                <a:spcAft>
-                  <a:spcPct val="0"/>
-                </a:spcAft>
-                <a:buClrTx/>
-                <a:buSzTx/>
-                <a:buFontTx/>
-                <a:buNone/>
-                <a:tabLst/>
-                <a:defRPr/>
-              </a:pPr>
-              <a:t>7</a:t>
-            </a:fld>
-            <a:endParaRPr kumimoji="0" lang="en-US" sz="1200" b="0" i="0" u="none" strike="noStrike" kern="1200" cap="none" spc="0" normalizeH="0" baseline="0" noProof="0">
-              <a:ln>
-                <a:noFill/>
-              </a:ln>
-              <a:solidFill>
-                <a:prstClr val="black"/>
-              </a:solidFill>
-              <a:effectLst/>
-              <a:uLnTx/>
-              <a:uFillTx/>
-              <a:latin typeface="Calibri" pitchFamily="34" charset="0"/>
-              <a:ea typeface="ＭＳ Ｐゴシック" pitchFamily="1" charset="-128"/>
-              <a:cs typeface="+mn-cs"/>
-            </a:endParaRPr>
-          </a:p>
-        </p:txBody>
-      </p:sp>
-    </p:spTree>
-    <p:extLst>
-      <p:ext uri="{BB962C8B-B14F-4D97-AF65-F5344CB8AC3E}">
         <p14:creationId xmlns:p14="http://schemas.microsoft.com/office/powerpoint/2010/main" val="1908672725"/>
       </p:ext>
     </p:extLst>
@@ -1736,7 +1558,7 @@
           <a:p>
             <a:fld id="{E60792E3-D524-454C-8AFD-A91972900BCB}" type="datetime1">
               <a:rPr lang="en-US" smtClean="0"/>
-              <a:t>7/24/2026</a:t>
+              <a:t>7/25/2026</a:t>
             </a:fld>
             <a:endParaRPr lang="en-US"/>
           </a:p>
@@ -1918,7 +1740,7 @@
           <a:p>
             <a:fld id="{053C3A68-6922-42D3-8905-ECC2D82A3469}" type="datetime1">
               <a:rPr lang="en-US" smtClean="0"/>
-              <a:t>7/24/2026</a:t>
+              <a:t>7/25/2026</a:t>
             </a:fld>
             <a:endParaRPr lang="en-US"/>
           </a:p>
@@ -2110,7 +1932,7 @@
           <a:p>
             <a:fld id="{CB69E9F4-7604-4950-A8B2-8ACDEDB1506E}" type="datetime1">
               <a:rPr lang="en-US" smtClean="0"/>
-              <a:t>7/24/2026</a:t>
+              <a:t>7/25/2026</a:t>
             </a:fld>
             <a:endParaRPr lang="en-US"/>
           </a:p>
@@ -2292,7 +2114,7 @@
           <a:p>
             <a:fld id="{708B7524-32A2-4C20-A58C-BC3BAA1042FC}" type="datetime1">
               <a:rPr lang="en-US" smtClean="0"/>
-              <a:t>7/24/2026</a:t>
+              <a:t>7/25/2026</a:t>
             </a:fld>
             <a:endParaRPr lang="en-US"/>
           </a:p>
@@ -2551,7 +2373,7 @@
           <a:p>
             <a:fld id="{1E994447-D6B2-43BB-A877-57F1A267B999}" type="datetime1">
               <a:rPr lang="en-US" smtClean="0"/>
-              <a:t>7/24/2026</a:t>
+              <a:t>7/25/2026</a:t>
             </a:fld>
             <a:endParaRPr lang="en-US"/>
           </a:p>
@@ -2850,7 +2672,7 @@
           <a:p>
             <a:fld id="{68920E16-BD35-483C-AA6B-346FC7E46DEA}" type="datetime1">
               <a:rPr lang="en-US" smtClean="0"/>
-              <a:t>7/24/2026</a:t>
+              <a:t>7/25/2026</a:t>
             </a:fld>
             <a:endParaRPr lang="en-US"/>
           </a:p>
@@ -3283,7 +3105,7 @@
           <a:p>
             <a:fld id="{2FEAC6F8-5103-4FC0-A69E-5C6AE6469DA8}" type="datetime1">
               <a:rPr lang="en-US" smtClean="0"/>
-              <a:t>7/24/2026</a:t>
+              <a:t>7/25/2026</a:t>
             </a:fld>
             <a:endParaRPr lang="en-US"/>
           </a:p>
@@ -3414,7 +3236,7 @@
           <a:p>
             <a:fld id="{C60C6921-0627-4C8F-83D5-0CF936D2FFDD}" type="datetime1">
               <a:rPr lang="en-US" smtClean="0"/>
-              <a:t>7/24/2026</a:t>
+              <a:t>7/25/2026</a:t>
             </a:fld>
             <a:endParaRPr lang="en-US"/>
           </a:p>
@@ -3523,7 +3345,7 @@
           <a:p>
             <a:fld id="{2FF08AD7-8103-40F8-983C-E2BA6BB9CBE0}" type="datetime1">
               <a:rPr lang="en-US" smtClean="0"/>
-              <a:t>7/24/2026</a:t>
+              <a:t>7/25/2026</a:t>
             </a:fld>
             <a:endParaRPr lang="en-US"/>
           </a:p>
@@ -3812,7 +3634,7 @@
           <a:p>
             <a:fld id="{DF8C06B4-9380-4A4D-AF49-A3596E17DAF5}" type="datetime1">
               <a:rPr lang="en-US" smtClean="0"/>
-              <a:t>7/24/2026</a:t>
+              <a:t>7/25/2026</a:t>
             </a:fld>
             <a:endParaRPr lang="en-US"/>
           </a:p>
@@ -4081,7 +3903,7 @@
           <a:p>
             <a:fld id="{EF7FDEF1-C582-4E22-9E77-D68326471F28}" type="datetime1">
               <a:rPr lang="en-US" smtClean="0"/>
-              <a:t>7/24/2026</a:t>
+              <a:t>7/25/2026</a:t>
             </a:fld>
             <a:endParaRPr lang="en-US"/>
           </a:p>
@@ -4324,7 +4146,7 @@
           <a:p>
             <a:fld id="{780A9602-A9A9-453F-AEF1-37B5837E02CD}" type="datetime1">
               <a:rPr lang="en-US" smtClean="0"/>
-              <a:t>7/24/2026</a:t>
+              <a:t>7/25/2026</a:t>
             </a:fld>
             <a:endParaRPr lang="en-US"/>
           </a:p>
@@ -4861,12 +4683,18 @@
       </p:grpSpPr>
       <p:sp>
         <p:nvSpPr>
-          <p:cNvPr id="6" name="Slide Number Placeholder 5"/>
-          <p:cNvSpPr>
-            <a:spLocks noGrp="1"/>
-          </p:cNvSpPr>
-          <p:nvPr>
-            <p:ph type="sldNum" sz="quarter" idx="12"/>
+          <p:cNvPr id="4" name="Footer Placeholder 3">
+            <a:extLst>
+              <a:ext uri="{FF2B5EF4-FFF2-40B4-BE49-F238E27FC236}">
+                <a16:creationId xmlns:a16="http://schemas.microsoft.com/office/drawing/2014/main" id="{C2A033A5-F70E-7E73-0B8C-FA62C08DEB56}"/>
+              </a:ext>
+            </a:extLst>
+          </p:cNvPr>
+          <p:cNvSpPr>
+            <a:spLocks noGrp="1"/>
+          </p:cNvSpPr>
+          <p:nvPr>
+            <p:ph type="ftr" sz="quarter" idx="11"/>
           </p:nvPr>
         </p:nvSpPr>
         <p:spPr/>
@@ -4874,209 +4702,302 @@
           <a:bodyPr/>
           <a:lstStyle/>
           <a:p>
-            <a:pPr marL="0" marR="0" lvl="0" indent="0" algn="r" defTabSz="457200" rtl="0" eaLnBrk="1" fontAlgn="base" latinLnBrk="0" hangingPunct="1">
-              <a:lnSpc>
-                <a:spcPct val="100000"/>
-              </a:lnSpc>
-              <a:spcBef>
-                <a:spcPct val="0"/>
-              </a:spcBef>
-              <a:spcAft>
-                <a:spcPct val="0"/>
-              </a:spcAft>
-              <a:buClrTx/>
-              <a:buSzTx/>
-              <a:buFontTx/>
-              <a:buNone/>
-              <a:tabLst/>
+            <a:pPr>
               <a:defRPr/>
             </a:pPr>
+            <a:r>
+              <a:rPr lang="en-US"/>
+              <a:t>@SIH Idea submission- Template</a:t>
+            </a:r>
+          </a:p>
+        </p:txBody>
+      </p:sp>
+      <p:sp>
+        <p:nvSpPr>
+          <p:cNvPr id="5" name="Slide Number Placeholder 4">
+            <a:extLst>
+              <a:ext uri="{FF2B5EF4-FFF2-40B4-BE49-F238E27FC236}">
+                <a16:creationId xmlns:a16="http://schemas.microsoft.com/office/drawing/2014/main" id="{EC99EC04-BCF1-5A69-7D5A-95D43C9763A1}"/>
+              </a:ext>
+            </a:extLst>
+          </p:cNvPr>
+          <p:cNvSpPr>
+            <a:spLocks noGrp="1"/>
+          </p:cNvSpPr>
+          <p:nvPr>
+            <p:ph type="sldNum" sz="quarter" idx="12"/>
+          </p:nvPr>
+        </p:nvSpPr>
+        <p:spPr/>
+        <p:txBody>
+          <a:bodyPr/>
+          <a:lstStyle/>
+          <a:p>
             <a:fld id="{677C3CE7-23F7-4828-823C-E0205DF2CF97}" type="slidenum">
-              <a:rPr kumimoji="0" lang="en-US" sz="1200" b="1" i="0" u="none" strike="noStrike" kern="1200" cap="none" spc="0" normalizeH="0" baseline="0" noProof="0">
-                <a:ln>
-                  <a:noFill/>
-                </a:ln>
-                <a:solidFill>
-                  <a:prstClr val="white"/>
-                </a:solidFill>
-                <a:effectLst/>
-                <a:uLnTx/>
-                <a:uFillTx/>
-                <a:latin typeface="TradeGothic" pitchFamily="1" charset="0"/>
-                <a:ea typeface="ＭＳ Ｐゴシック" pitchFamily="1" charset="-128"/>
-                <a:cs typeface="+mn-cs"/>
-              </a:rPr>
-              <a:pPr marL="0" marR="0" lvl="0" indent="0" algn="r" defTabSz="457200" rtl="0" eaLnBrk="1" fontAlgn="base" latinLnBrk="0" hangingPunct="1">
-                <a:lnSpc>
-                  <a:spcPct val="100000"/>
-                </a:lnSpc>
-                <a:spcBef>
-                  <a:spcPct val="0"/>
-                </a:spcBef>
-                <a:spcAft>
-                  <a:spcPct val="0"/>
-                </a:spcAft>
-                <a:buClrTx/>
-                <a:buSzTx/>
-                <a:buFontTx/>
-                <a:buNone/>
-                <a:tabLst/>
-                <a:defRPr/>
-              </a:pPr>
+              <a:rPr lang="en-US" smtClean="0"/>
+              <a:pPr/>
               <a:t>1</a:t>
             </a:fld>
-            <a:endParaRPr kumimoji="0" lang="en-US" sz="1200" b="1" i="0" u="none" strike="noStrike" kern="1200" cap="none" spc="0" normalizeH="0" baseline="0" noProof="0" dirty="0">
-              <a:ln>
-                <a:noFill/>
-              </a:ln>
-              <a:solidFill>
-                <a:prstClr val="white"/>
-              </a:solidFill>
-              <a:effectLst/>
-              <a:uLnTx/>
-              <a:uFillTx/>
-              <a:latin typeface="TradeGothic" pitchFamily="1" charset="0"/>
-              <a:ea typeface="ＭＳ Ｐゴシック" pitchFamily="1" charset="-128"/>
-              <a:cs typeface="+mn-cs"/>
-            </a:endParaRPr>
-          </a:p>
-        </p:txBody>
-      </p:sp>
-      <p:sp>
-        <p:nvSpPr>
-          <p:cNvPr id="7" name="Footer Placeholder 6"/>
-          <p:cNvSpPr>
-            <a:spLocks noGrp="1"/>
-          </p:cNvSpPr>
-          <p:nvPr>
-            <p:ph type="ftr" sz="quarter" idx="11"/>
-          </p:nvPr>
-        </p:nvSpPr>
-        <p:spPr>
+            <a:endParaRPr lang="en-US"/>
+          </a:p>
+        </p:txBody>
+      </p:sp>
+      <p:sp>
+        <p:nvSpPr>
+          <p:cNvPr id="6" name="Subtitle 3">
+            <a:extLst>
+              <a:ext uri="{FF2B5EF4-FFF2-40B4-BE49-F238E27FC236}">
+                <a16:creationId xmlns:a16="http://schemas.microsoft.com/office/drawing/2014/main" id="{E0A8E5C6-6BFC-01E5-DDF5-B6A7738A64F4}"/>
+              </a:ext>
+            </a:extLst>
+          </p:cNvPr>
+          <p:cNvSpPr txBox="1">
+            <a:spLocks/>
+          </p:cNvSpPr>
+          <p:nvPr/>
+        </p:nvSpPr>
+        <p:spPr bwMode="auto">
           <a:xfrm>
-            <a:off x="4648200" y="6356353"/>
-            <a:ext cx="3204000" cy="365125"/>
-          </a:xfrm>
-        </p:spPr>
-        <p:txBody>
-          <a:bodyPr/>
-          <a:lstStyle/>
-          <a:p>
-            <a:pPr marL="0" marR="0" lvl="0" indent="0" algn="ctr" defTabSz="457200" rtl="0" eaLnBrk="1" fontAlgn="auto" latinLnBrk="0" hangingPunct="1">
-              <a:lnSpc>
-                <a:spcPct val="100000"/>
-              </a:lnSpc>
-              <a:spcBef>
-                <a:spcPts val="0"/>
-              </a:spcBef>
-              <a:spcAft>
-                <a:spcPts val="0"/>
-              </a:spcAft>
-              <a:buClrTx/>
-              <a:buSzTx/>
-              <a:buFontTx/>
-              <a:buNone/>
-              <a:tabLst/>
-              <a:defRPr/>
-            </a:pPr>
-            <a:r>
-              <a:rPr kumimoji="0" lang="en-US" sz="1200" b="0" i="0" u="none" strike="noStrike" kern="1200" cap="none" spc="0" normalizeH="0" baseline="0" noProof="0">
-                <a:ln>
-                  <a:noFill/>
-                </a:ln>
-                <a:solidFill>
-                  <a:prstClr val="white"/>
-                </a:solidFill>
-                <a:effectLst/>
-                <a:uLnTx/>
-                <a:uFillTx/>
-                <a:latin typeface="TradeGothic"/>
-                <a:ea typeface="+mn-ea"/>
-                <a:cs typeface="+mn-cs"/>
-              </a:rPr>
-              <a:t>@SIH Idea submission- Template</a:t>
-            </a:r>
-            <a:endParaRPr kumimoji="0" lang="en-US" sz="1200" b="0" i="0" u="none" strike="noStrike" kern="1200" cap="none" spc="0" normalizeH="0" baseline="0" noProof="0" dirty="0">
-              <a:ln>
-                <a:noFill/>
-              </a:ln>
-              <a:solidFill>
-                <a:prstClr val="white"/>
-              </a:solidFill>
-              <a:effectLst/>
-              <a:uLnTx/>
-              <a:uFillTx/>
-              <a:latin typeface="TradeGothic"/>
-              <a:ea typeface="+mn-ea"/>
-              <a:cs typeface="+mn-cs"/>
-            </a:endParaRPr>
-          </a:p>
-        </p:txBody>
-      </p:sp>
-      <p:sp>
-        <p:nvSpPr>
-          <p:cNvPr id="12" name="Google Shape;100;p3"/>
-          <p:cNvSpPr txBox="1"/>
-          <p:nvPr/>
-        </p:nvSpPr>
-        <p:spPr>
-          <a:xfrm>
-            <a:off x="367832" y="1915454"/>
-            <a:ext cx="11764736" cy="4070356"/>
+            <a:off x="1415369" y="-365784"/>
+            <a:ext cx="8534400" cy="1752600"/>
           </a:xfrm>
           <a:prstGeom prst="rect">
             <a:avLst/>
           </a:prstGeom>
           <a:noFill/>
-          <a:ln>
+          <a:ln w="9525">
             <a:noFill/>
+            <a:miter lim="800000"/>
+            <a:headEnd/>
+            <a:tailEnd/>
           </a:ln>
         </p:spPr>
         <p:txBody>
-          <a:bodyPr spcFirstLastPara="1" wrap="square" lIns="91425" tIns="45700" rIns="91425" bIns="45700" anchor="t" anchorCtr="0">
-            <a:noAutofit/>
+          <a:bodyPr vert="horz" wrap="square" lIns="91440" tIns="45720" rIns="91440" bIns="45720" numCol="1" anchor="t" anchorCtr="0" compatLnSpc="1">
+            <a:prstTxWarp prst="textNoShape">
+              <a:avLst/>
+            </a:prstTxWarp>
           </a:bodyPr>
-          <a:lstStyle/>
-          <a:p>
-            <a:pPr marL="914400" marR="0" lvl="1" indent="-316230" algn="just" rtl="0">
-              <a:lnSpc>
-                <a:spcPct val="90000"/>
-              </a:lnSpc>
+          <a:lstStyle>
+            <a:lvl1pPr marL="0" indent="0" algn="ctr" defTabSz="457200" rtl="0" eaLnBrk="0" fontAlgn="base" hangingPunct="0">
               <a:spcBef>
-                <a:spcPts val="500"/>
+                <a:spcPct val="20000"/>
               </a:spcBef>
               <a:spcAft>
-                <a:spcPts val="0"/>
+                <a:spcPct val="0"/>
               </a:spcAft>
-              <a:buClr>
-                <a:schemeClr val="dk1"/>
-              </a:buClr>
-              <a:buSzPct val="100000"/>
-              <a:buFont typeface="Calibri"/>
-              <a:buNone/>
-            </a:pPr>
-            <a:endParaRPr sz="2000" b="1" i="0" u="none" strike="noStrike" cap="none" dirty="0">
+              <a:buFont typeface="Arial" pitchFamily="34" charset="0"/>
+              <a:buNone/>
+              <a:defRPr sz="3200" kern="1200">
+                <a:solidFill>
+                  <a:schemeClr val="tx1">
+                    <a:tint val="75000"/>
+                  </a:schemeClr>
+                </a:solidFill>
+                <a:latin typeface="TradeGothic"/>
+                <a:ea typeface="ＭＳ Ｐゴシック" charset="0"/>
+                <a:cs typeface="ＭＳ Ｐゴシック" charset="0"/>
+              </a:defRPr>
+            </a:lvl1pPr>
+            <a:lvl2pPr marL="457200" indent="0" algn="ctr" defTabSz="457200" rtl="0" eaLnBrk="0" fontAlgn="base" hangingPunct="0">
+              <a:spcBef>
+                <a:spcPct val="20000"/>
+              </a:spcBef>
+              <a:spcAft>
+                <a:spcPct val="0"/>
+              </a:spcAft>
+              <a:buFont typeface="Arial" pitchFamily="34" charset="0"/>
+              <a:buNone/>
+              <a:defRPr sz="2800" kern="1200">
+                <a:solidFill>
+                  <a:schemeClr val="tx1">
+                    <a:tint val="75000"/>
+                  </a:schemeClr>
+                </a:solidFill>
+                <a:latin typeface="TradeGothic"/>
+                <a:ea typeface="ＭＳ Ｐゴシック" charset="0"/>
+                <a:cs typeface="+mn-cs"/>
+              </a:defRPr>
+            </a:lvl2pPr>
+            <a:lvl3pPr marL="914400" indent="0" algn="ctr" defTabSz="457200" rtl="0" eaLnBrk="0" fontAlgn="base" hangingPunct="0">
+              <a:spcBef>
+                <a:spcPct val="20000"/>
+              </a:spcBef>
+              <a:spcAft>
+                <a:spcPct val="0"/>
+              </a:spcAft>
+              <a:buFont typeface="Arial" pitchFamily="34" charset="0"/>
+              <a:buNone/>
+              <a:defRPr sz="2400" kern="1200">
+                <a:solidFill>
+                  <a:schemeClr val="tx1">
+                    <a:tint val="75000"/>
+                  </a:schemeClr>
+                </a:solidFill>
+                <a:latin typeface="TradeGothic"/>
+                <a:ea typeface="ＭＳ Ｐゴシック" charset="0"/>
+                <a:cs typeface="+mn-cs"/>
+              </a:defRPr>
+            </a:lvl3pPr>
+            <a:lvl4pPr marL="1371600" indent="0" algn="ctr" defTabSz="457200" rtl="0" eaLnBrk="0" fontAlgn="base" hangingPunct="0">
+              <a:spcBef>
+                <a:spcPct val="20000"/>
+              </a:spcBef>
+              <a:spcAft>
+                <a:spcPct val="0"/>
+              </a:spcAft>
+              <a:buFont typeface="Arial" pitchFamily="34" charset="0"/>
+              <a:buNone/>
+              <a:defRPr sz="2000" kern="1200">
+                <a:solidFill>
+                  <a:schemeClr val="tx1">
+                    <a:tint val="75000"/>
+                  </a:schemeClr>
+                </a:solidFill>
+                <a:latin typeface="TradeGothic"/>
+                <a:ea typeface="ＭＳ Ｐゴシック" charset="0"/>
+                <a:cs typeface="+mn-cs"/>
+              </a:defRPr>
+            </a:lvl4pPr>
+            <a:lvl5pPr marL="1828800" indent="0" algn="ctr" defTabSz="457200" rtl="0" eaLnBrk="0" fontAlgn="base" hangingPunct="0">
+              <a:spcBef>
+                <a:spcPct val="20000"/>
+              </a:spcBef>
+              <a:spcAft>
+                <a:spcPct val="0"/>
+              </a:spcAft>
+              <a:buFont typeface="Arial" pitchFamily="34" charset="0"/>
+              <a:buNone/>
+              <a:defRPr sz="2000" kern="1200">
+                <a:solidFill>
+                  <a:schemeClr val="tx1">
+                    <a:tint val="75000"/>
+                  </a:schemeClr>
+                </a:solidFill>
+                <a:latin typeface="TradeGothic"/>
+                <a:ea typeface="ＭＳ Ｐゴシック" charset="0"/>
+                <a:cs typeface="+mn-cs"/>
+              </a:defRPr>
+            </a:lvl5pPr>
+            <a:lvl6pPr marL="2286000" indent="0" algn="ctr" defTabSz="457200" rtl="0" eaLnBrk="1" latinLnBrk="0" hangingPunct="1">
+              <a:spcBef>
+                <a:spcPct val="20000"/>
+              </a:spcBef>
+              <a:buFont typeface="Arial"/>
+              <a:buNone/>
+              <a:defRPr sz="2000" kern="1200">
+                <a:solidFill>
+                  <a:schemeClr val="tx1">
+                    <a:tint val="75000"/>
+                  </a:schemeClr>
+                </a:solidFill>
+                <a:latin typeface="+mn-lt"/>
+                <a:ea typeface="+mn-ea"/>
+                <a:cs typeface="+mn-cs"/>
+              </a:defRPr>
+            </a:lvl6pPr>
+            <a:lvl7pPr marL="2743200" indent="0" algn="ctr" defTabSz="457200" rtl="0" eaLnBrk="1" latinLnBrk="0" hangingPunct="1">
+              <a:spcBef>
+                <a:spcPct val="20000"/>
+              </a:spcBef>
+              <a:buFont typeface="Arial"/>
+              <a:buNone/>
+              <a:defRPr sz="2000" kern="1200">
+                <a:solidFill>
+                  <a:schemeClr val="tx1">
+                    <a:tint val="75000"/>
+                  </a:schemeClr>
+                </a:solidFill>
+                <a:latin typeface="+mn-lt"/>
+                <a:ea typeface="+mn-ea"/>
+                <a:cs typeface="+mn-cs"/>
+              </a:defRPr>
+            </a:lvl7pPr>
+            <a:lvl8pPr marL="3200400" indent="0" algn="ctr" defTabSz="457200" rtl="0" eaLnBrk="1" latinLnBrk="0" hangingPunct="1">
+              <a:spcBef>
+                <a:spcPct val="20000"/>
+              </a:spcBef>
+              <a:buFont typeface="Arial"/>
+              <a:buNone/>
+              <a:defRPr sz="2000" kern="1200">
+                <a:solidFill>
+                  <a:schemeClr val="tx1">
+                    <a:tint val="75000"/>
+                  </a:schemeClr>
+                </a:solidFill>
+                <a:latin typeface="+mn-lt"/>
+                <a:ea typeface="+mn-ea"/>
+                <a:cs typeface="+mn-cs"/>
+              </a:defRPr>
+            </a:lvl8pPr>
+            <a:lvl9pPr marL="3657600" indent="0" algn="ctr" defTabSz="457200" rtl="0" eaLnBrk="1" latinLnBrk="0" hangingPunct="1">
+              <a:spcBef>
+                <a:spcPct val="20000"/>
+              </a:spcBef>
+              <a:buFont typeface="Arial"/>
+              <a:buNone/>
+              <a:defRPr sz="2000" kern="1200">
+                <a:solidFill>
+                  <a:schemeClr val="tx1">
+                    <a:tint val="75000"/>
+                  </a:schemeClr>
+                </a:solidFill>
+                <a:latin typeface="+mn-lt"/>
+                <a:ea typeface="+mn-ea"/>
+                <a:cs typeface="+mn-cs"/>
+              </a:defRPr>
+            </a:lvl9pPr>
+          </a:lstStyle>
+          <a:p>
+            <a:pPr>
+              <a:defRPr sz="2800" b="1">
+                <a:solidFill>
+                  <a:srgbClr val="1D4ED8"/>
+                </a:solidFill>
+                <a:latin typeface="Arial"/>
+              </a:defRPr>
+            </a:pPr>
+            <a:endParaRPr lang="en-US" dirty="0"/>
+          </a:p>
+          <a:p>
+            <a:pPr>
+              <a:defRPr sz="2800" b="1">
+                <a:solidFill>
+                  <a:srgbClr val="1D4ED8"/>
+                </a:solidFill>
+                <a:latin typeface="Arial"/>
+              </a:defRPr>
+            </a:pPr>
+            <a:r>
+              <a:rPr dirty="0"/>
+              <a:t>AUTONOMOUS CHOKE CONTROLLER FOR AN OIL WELL</a:t>
+            </a:r>
+            <a:endParaRPr lang="en-US" b="1" dirty="0">
               <a:solidFill>
-                <a:schemeClr val="dk1"/>
+                <a:schemeClr val="tx1"/>
               </a:solidFill>
-              <a:latin typeface="Arial" panose="020B0604020202020204" pitchFamily="34" charset="0"/>
-              <a:ea typeface="Calibri"/>
-              <a:cs typeface="Arial" panose="020B0604020202020204" pitchFamily="34" charset="0"/>
-              <a:sym typeface="Calibri"/>
+              <a:latin typeface="Times New Roman" panose="02020603050405020304" pitchFamily="18" charset="0"/>
+              <a:cs typeface="Times New Roman" panose="02020603050405020304" pitchFamily="18" charset="0"/>
             </a:endParaRPr>
           </a:p>
         </p:txBody>
       </p:sp>
       <p:sp>
         <p:nvSpPr>
-          <p:cNvPr id="4" name="TextBox 3"/>
+          <p:cNvPr id="7" name="TextBox 6">
+            <a:extLst>
+              <a:ext uri="{FF2B5EF4-FFF2-40B4-BE49-F238E27FC236}">
+                <a16:creationId xmlns:a16="http://schemas.microsoft.com/office/drawing/2014/main" id="{AFB1BDE7-2DA0-F526-CF6E-F50D43C2C5FE}"/>
+              </a:ext>
+            </a:extLst>
+          </p:cNvPr>
           <p:cNvSpPr txBox="1"/>
           <p:nvPr/>
         </p:nvSpPr>
         <p:spPr>
           <a:xfrm>
-            <a:off x="1393371" y="107066"/>
-            <a:ext cx="8410540" cy="646331"/>
+            <a:off x="397274" y="1203454"/>
+            <a:ext cx="5924550" cy="4686668"/>
           </a:xfrm>
           <a:prstGeom prst="rect">
             <a:avLst/>
@@ -5089,485 +5010,87 @@
           </a:bodyPr>
           <a:lstStyle/>
           <a:p>
-            <a:pPr algn="ctr"/>
-            <a:r>
-              <a:rPr lang="en-US" sz="3600" b="1" dirty="0">
-                <a:latin typeface="Times New Roman" panose="02020603050405020304" pitchFamily="18" charset="0"/>
-                <a:cs typeface="Times New Roman" panose="02020603050405020304" pitchFamily="18" charset="0"/>
-              </a:rPr>
-              <a:t>IMPORTANT INSTRUCTIONS</a:t>
-            </a:r>
-            <a:endParaRPr lang="en-IN" sz="3600" b="1" dirty="0">
-              <a:latin typeface="Times New Roman" panose="02020603050405020304" pitchFamily="18" charset="0"/>
-              <a:cs typeface="Times New Roman" panose="02020603050405020304" pitchFamily="18" charset="0"/>
-            </a:endParaRPr>
-          </a:p>
-        </p:txBody>
-      </p:sp>
-      <p:sp>
-        <p:nvSpPr>
-          <p:cNvPr id="5" name="TextBox 4"/>
-          <p:cNvSpPr txBox="1"/>
-          <p:nvPr/>
-        </p:nvSpPr>
-        <p:spPr>
-          <a:xfrm>
-            <a:off x="602343" y="1181900"/>
-            <a:ext cx="9557657" cy="341632"/>
-          </a:xfrm>
-          <a:prstGeom prst="rect">
-            <a:avLst/>
-          </a:prstGeom>
-          <a:noFill/>
-        </p:spPr>
-        <p:txBody>
-          <a:bodyPr wrap="square" rtlCol="0">
-            <a:spAutoFit/>
-          </a:bodyPr>
-          <a:lstStyle/>
-          <a:p>
-            <a:pPr algn="just">
-              <a:lnSpc>
-                <a:spcPct val="90000"/>
-              </a:lnSpc>
-              <a:spcBef>
-                <a:spcPts val="1000"/>
-              </a:spcBef>
+            <a:pPr>
               <a:spcAft>
-                <a:spcPts val="0"/>
+                <a:spcPts val="800"/>
               </a:spcAft>
-              <a:buClr>
-                <a:schemeClr val="dk1"/>
-              </a:buClr>
-              <a:buSzPct val="100000"/>
-            </a:pPr>
-            <a:r>
-              <a:rPr lang="en-US" b="1" dirty="0">
-                <a:solidFill>
-                  <a:schemeClr val="dk1"/>
-                </a:solidFill>
-                <a:latin typeface="Arial" panose="020B0604020202020204" pitchFamily="34" charset="0"/>
-                <a:ea typeface="Calibri"/>
-                <a:cs typeface="Arial" panose="020B0604020202020204" pitchFamily="34" charset="0"/>
-              </a:rPr>
-              <a:t>Please ensure below pointers are met while submitting the Idea PPT:</a:t>
-            </a:r>
-            <a:endParaRPr lang="en-IN" b="1" dirty="0">
-              <a:solidFill>
-                <a:schemeClr val="dk1"/>
-              </a:solidFill>
-              <a:latin typeface="Arial" panose="020B0604020202020204" pitchFamily="34" charset="0"/>
-              <a:ea typeface="Calibri"/>
-              <a:cs typeface="Arial" panose="020B0604020202020204" pitchFamily="34" charset="0"/>
-            </a:endParaRPr>
-          </a:p>
-        </p:txBody>
-      </p:sp>
-      <p:sp>
-        <p:nvSpPr>
-          <p:cNvPr id="9" name="TextBox 8">
-            <a:extLst>
-              <a:ext uri="{FF2B5EF4-FFF2-40B4-BE49-F238E27FC236}">
-                <a16:creationId xmlns:a16="http://schemas.microsoft.com/office/drawing/2014/main" id="{327CE727-C45C-A6F5-9EE5-AF363B2ADA27}"/>
-              </a:ext>
-            </a:extLst>
-          </p:cNvPr>
-          <p:cNvSpPr txBox="1"/>
-          <p:nvPr/>
-        </p:nvSpPr>
-        <p:spPr>
-          <a:xfrm>
-            <a:off x="602343" y="1714078"/>
-            <a:ext cx="10397765" cy="4073423"/>
-          </a:xfrm>
-          <a:prstGeom prst="rect">
-            <a:avLst/>
-          </a:prstGeom>
-          <a:noFill/>
-        </p:spPr>
-        <p:txBody>
-          <a:bodyPr wrap="square">
-            <a:spAutoFit/>
-          </a:bodyPr>
-          <a:lstStyle/>
-          <a:p>
-            <a:pPr marL="514350" marR="0" lvl="0" indent="-514350" algn="just" rtl="0">
-              <a:lnSpc>
-                <a:spcPct val="90000"/>
-              </a:lnSpc>
-              <a:spcBef>
-                <a:spcPts val="0"/>
-              </a:spcBef>
+              <a:defRPr sz="1800">
+                <a:latin typeface="Arial"/>
+              </a:defRPr>
+            </a:pPr>
+            <a:r>
+              <a:t>Problem Statement ID: SIH1747</a:t>
+            </a:r>
+            <a:endParaRPr lang="en-US" dirty="0"/>
+          </a:p>
+          <a:p>
+            <a:pPr>
               <a:spcAft>
-                <a:spcPts val="0"/>
+                <a:spcPts val="800"/>
               </a:spcAft>
-              <a:buClr>
-                <a:schemeClr val="dk1"/>
-              </a:buClr>
-              <a:buSzPct val="100000"/>
-              <a:buFont typeface="Calibri"/>
-              <a:buAutoNum type="arabicPeriod"/>
-            </a:pPr>
-            <a:r>
-              <a:rPr lang="en-US" b="1" i="0" u="none" strike="noStrike" cap="none" dirty="0">
-                <a:solidFill>
-                  <a:schemeClr val="dk1"/>
-                </a:solidFill>
-                <a:latin typeface="Arial" panose="020B0604020202020204" pitchFamily="34" charset="0"/>
-                <a:ea typeface="Calibri"/>
-                <a:cs typeface="Arial" panose="020B0604020202020204" pitchFamily="34" charset="0"/>
-                <a:sym typeface="Calibri"/>
-              </a:rPr>
-              <a:t>Kindly keep the maximum slides limit up to six </a:t>
-            </a:r>
-            <a:r>
-              <a:rPr lang="en-US" b="1" i="0" u="none" strike="noStrike" cap="none" dirty="0">
-                <a:solidFill>
-                  <a:srgbClr val="C00000"/>
-                </a:solidFill>
-                <a:latin typeface="Arial" panose="020B0604020202020204" pitchFamily="34" charset="0"/>
-                <a:ea typeface="Calibri"/>
-                <a:cs typeface="Arial" panose="020B0604020202020204" pitchFamily="34" charset="0"/>
-                <a:sym typeface="Calibri"/>
-              </a:rPr>
-              <a:t>(6). </a:t>
-            </a:r>
-            <a:r>
-              <a:rPr lang="en-US" b="1" i="0" u="none" strike="noStrike" cap="none" dirty="0">
-                <a:solidFill>
-                  <a:schemeClr val="dk1"/>
-                </a:solidFill>
-                <a:latin typeface="Arial" panose="020B0604020202020204" pitchFamily="34" charset="0"/>
-                <a:ea typeface="Calibri"/>
-                <a:cs typeface="Arial" panose="020B0604020202020204" pitchFamily="34" charset="0"/>
-                <a:sym typeface="Calibri"/>
-              </a:rPr>
-              <a:t>( Including the title slide) </a:t>
-            </a:r>
-            <a:endParaRPr lang="en-US" b="1" dirty="0">
-              <a:latin typeface="Arial" panose="020B0604020202020204" pitchFamily="34" charset="0"/>
-              <a:cs typeface="Arial" panose="020B0604020202020204" pitchFamily="34" charset="0"/>
-            </a:endParaRPr>
-          </a:p>
-          <a:p>
-            <a:pPr marL="514350" marR="0" lvl="0" indent="-514350" algn="just" rtl="0">
-              <a:lnSpc>
-                <a:spcPct val="90000"/>
-              </a:lnSpc>
-              <a:spcBef>
-                <a:spcPts val="1000"/>
-              </a:spcBef>
+              <a:defRPr sz="1800" b="1">
+                <a:latin typeface="Arial"/>
+              </a:defRPr>
+            </a:pPr>
+            <a:r>
+              <a:t>Problem Statement Title: Autonomous Choke Control for a Single Naturally Flowing Oil Well</a:t>
+            </a:r>
+          </a:p>
+          <a:p>
+            <a:pPr>
               <a:spcAft>
-                <a:spcPts val="0"/>
+                <a:spcPts val="800"/>
               </a:spcAft>
-              <a:buClr>
-                <a:schemeClr val="dk1"/>
-              </a:buClr>
-              <a:buSzPct val="100000"/>
-              <a:buFont typeface="Calibri"/>
-              <a:buAutoNum type="arabicPeriod"/>
-            </a:pPr>
-            <a:r>
-              <a:rPr lang="en-US" b="1" i="0" u="none" strike="noStrike" cap="none" dirty="0">
-                <a:solidFill>
-                  <a:schemeClr val="dk1"/>
-                </a:solidFill>
-                <a:latin typeface="Arial" panose="020B0604020202020204" pitchFamily="34" charset="0"/>
-                <a:ea typeface="Calibri"/>
-                <a:cs typeface="Arial" panose="020B0604020202020204" pitchFamily="34" charset="0"/>
-                <a:sym typeface="Calibri"/>
-              </a:rPr>
-              <a:t>Try to avoid paragraphs and post your idea in points /diagrams / Infographics /pictures </a:t>
-            </a:r>
-            <a:endParaRPr lang="en-US" b="1" dirty="0">
-              <a:latin typeface="Arial" panose="020B0604020202020204" pitchFamily="34" charset="0"/>
-              <a:cs typeface="Arial" panose="020B0604020202020204" pitchFamily="34" charset="0"/>
-            </a:endParaRPr>
-          </a:p>
-          <a:p>
-            <a:pPr marL="514350" marR="0" lvl="0" indent="-514350" algn="just" rtl="0">
-              <a:lnSpc>
-                <a:spcPct val="90000"/>
-              </a:lnSpc>
-              <a:spcBef>
-                <a:spcPts val="1000"/>
-              </a:spcBef>
+              <a:defRPr sz="1800">
+                <a:latin typeface="Arial"/>
+              </a:defRPr>
+            </a:pPr>
+            <a:r>
+              <a:t>Theme: Smart Automation &amp; Energy Systems</a:t>
+            </a:r>
+          </a:p>
+          <a:p>
+            <a:pPr>
               <a:spcAft>
-                <a:spcPts val="0"/>
+                <a:spcPts val="1600"/>
               </a:spcAft>
-              <a:buClr>
-                <a:schemeClr val="dk1"/>
-              </a:buClr>
-              <a:buSzPct val="100000"/>
-              <a:buFont typeface="Calibri"/>
-              <a:buAutoNum type="arabicPeriod"/>
-            </a:pPr>
-            <a:r>
-              <a:rPr lang="en-US" b="1" i="0" u="none" strike="noStrike" cap="none" dirty="0">
-                <a:solidFill>
-                  <a:schemeClr val="dk1"/>
-                </a:solidFill>
-                <a:latin typeface="Arial" panose="020B0604020202020204" pitchFamily="34" charset="0"/>
-                <a:ea typeface="Calibri"/>
-                <a:cs typeface="Arial" panose="020B0604020202020204" pitchFamily="34" charset="0"/>
-                <a:sym typeface="Calibri"/>
-              </a:rPr>
-              <a:t>Keep your explanation precise and easy to understand</a:t>
-            </a:r>
-            <a:endParaRPr lang="en-US" b="1" dirty="0">
-              <a:latin typeface="Arial" panose="020B0604020202020204" pitchFamily="34" charset="0"/>
-              <a:cs typeface="Arial" panose="020B0604020202020204" pitchFamily="34" charset="0"/>
-            </a:endParaRPr>
-          </a:p>
-          <a:p>
-            <a:pPr marL="514350" marR="0" lvl="0" indent="-514350" algn="just" rtl="0">
-              <a:lnSpc>
-                <a:spcPct val="90000"/>
-              </a:lnSpc>
-              <a:spcBef>
-                <a:spcPts val="1000"/>
-              </a:spcBef>
+              <a:defRPr sz="1800">
+                <a:latin typeface="Arial"/>
+              </a:defRPr>
+            </a:pPr>
+            <a:r>
+              <a:t>PS Category: Software / Algorithm</a:t>
+            </a:r>
+          </a:p>
+          <a:p>
+            <a:pPr>
               <a:spcAft>
-                <a:spcPts val="0"/>
+                <a:spcPts val="800"/>
               </a:spcAft>
-              <a:buClr>
-                <a:schemeClr val="dk1"/>
-              </a:buClr>
-              <a:buSzPct val="100000"/>
-              <a:buFont typeface="Calibri"/>
-              <a:buAutoNum type="arabicPeriod"/>
-            </a:pPr>
-            <a:r>
-              <a:rPr lang="en-US" b="1" i="0" u="none" strike="noStrike" cap="none" dirty="0">
-                <a:solidFill>
-                  <a:schemeClr val="dk1"/>
-                </a:solidFill>
-                <a:latin typeface="Arial" panose="020B0604020202020204" pitchFamily="34" charset="0"/>
-                <a:ea typeface="Calibri"/>
-                <a:cs typeface="Arial" panose="020B0604020202020204" pitchFamily="34" charset="0"/>
-                <a:sym typeface="Calibri"/>
-              </a:rPr>
-              <a:t>Idea should be unique and novel. </a:t>
-            </a:r>
-            <a:endParaRPr lang="en-US" b="1" dirty="0">
-              <a:latin typeface="Arial" panose="020B0604020202020204" pitchFamily="34" charset="0"/>
-              <a:cs typeface="Arial" panose="020B0604020202020204" pitchFamily="34" charset="0"/>
-            </a:endParaRPr>
-          </a:p>
-          <a:p>
-            <a:pPr marL="514350" marR="0" lvl="0" indent="-514350" algn="just" rtl="0">
-              <a:lnSpc>
-                <a:spcPct val="90000"/>
-              </a:lnSpc>
-              <a:spcBef>
-                <a:spcPts val="1000"/>
-              </a:spcBef>
-              <a:spcAft>
-                <a:spcPts val="0"/>
-              </a:spcAft>
-              <a:buClr>
-                <a:schemeClr val="dk1"/>
-              </a:buClr>
-              <a:buSzPct val="100000"/>
-              <a:buFont typeface="Calibri"/>
-              <a:buAutoNum type="arabicPeriod"/>
-            </a:pPr>
-            <a:r>
-              <a:rPr lang="en-US" b="1" i="0" u="none" strike="noStrike" cap="none" dirty="0">
-                <a:solidFill>
-                  <a:schemeClr val="dk1"/>
-                </a:solidFill>
-                <a:latin typeface="Arial" panose="020B0604020202020204" pitchFamily="34" charset="0"/>
-                <a:ea typeface="Calibri"/>
-                <a:cs typeface="Arial" panose="020B0604020202020204" pitchFamily="34" charset="0"/>
-                <a:sym typeface="Calibri"/>
-              </a:rPr>
-              <a:t>You can only use provided </a:t>
-            </a:r>
-            <a:r>
-              <a:rPr lang="en-US" b="1" dirty="0">
-                <a:solidFill>
-                  <a:schemeClr val="dk1"/>
-                </a:solidFill>
-                <a:latin typeface="Arial" panose="020B0604020202020204" pitchFamily="34" charset="0"/>
-                <a:ea typeface="Calibri"/>
-                <a:cs typeface="Arial" panose="020B0604020202020204" pitchFamily="34" charset="0"/>
-                <a:sym typeface="Calibri"/>
-              </a:rPr>
-              <a:t>template</a:t>
-            </a:r>
-            <a:r>
-              <a:rPr lang="en-US" b="1" i="0" u="none" strike="noStrike" cap="none" dirty="0">
-                <a:solidFill>
-                  <a:schemeClr val="dk1"/>
-                </a:solidFill>
-                <a:latin typeface="Arial" panose="020B0604020202020204" pitchFamily="34" charset="0"/>
-                <a:ea typeface="Calibri"/>
-                <a:cs typeface="Arial" panose="020B0604020202020204" pitchFamily="34" charset="0"/>
-                <a:sym typeface="Calibri"/>
-              </a:rPr>
-              <a:t> for making the </a:t>
-            </a:r>
-            <a:r>
-              <a:rPr lang="en-US" b="1" dirty="0">
-                <a:solidFill>
-                  <a:schemeClr val="dk1"/>
-                </a:solidFill>
-                <a:latin typeface="Arial" panose="020B0604020202020204" pitchFamily="34" charset="0"/>
-                <a:ea typeface="Calibri"/>
-                <a:cs typeface="Arial" panose="020B0604020202020204" pitchFamily="34" charset="0"/>
-                <a:sym typeface="Calibri"/>
-              </a:rPr>
-              <a:t>PPT</a:t>
-            </a:r>
-            <a:r>
-              <a:rPr lang="en-US" b="1" i="0" u="none" strike="noStrike" cap="none" dirty="0">
-                <a:solidFill>
-                  <a:schemeClr val="dk1"/>
-                </a:solidFill>
-                <a:latin typeface="Arial" panose="020B0604020202020204" pitchFamily="34" charset="0"/>
-                <a:ea typeface="Calibri"/>
-                <a:cs typeface="Arial" panose="020B0604020202020204" pitchFamily="34" charset="0"/>
-                <a:sym typeface="Calibri"/>
-              </a:rPr>
-              <a:t> without changing the idea details pointers (mentioned in previous slides).</a:t>
-            </a:r>
-          </a:p>
-          <a:p>
-            <a:pPr marL="514350" marR="0" lvl="0" indent="-514350" algn="just" rtl="0">
-              <a:lnSpc>
-                <a:spcPct val="90000"/>
-              </a:lnSpc>
-              <a:spcBef>
-                <a:spcPts val="1000"/>
-              </a:spcBef>
-              <a:spcAft>
-                <a:spcPts val="0"/>
-              </a:spcAft>
-              <a:buClr>
-                <a:schemeClr val="dk1"/>
-              </a:buClr>
-              <a:buSzPct val="100000"/>
-              <a:buFont typeface="Calibri"/>
-              <a:buAutoNum type="arabicPeriod"/>
-            </a:pPr>
-            <a:r>
-              <a:rPr lang="en-US" b="1" i="0" u="none" strike="noStrike" cap="none" dirty="0">
-                <a:solidFill>
-                  <a:schemeClr val="dk1"/>
-                </a:solidFill>
-                <a:latin typeface="Arial" panose="020B0604020202020204" pitchFamily="34" charset="0"/>
-                <a:ea typeface="Calibri"/>
-                <a:cs typeface="Arial" panose="020B0604020202020204" pitchFamily="34" charset="0"/>
-                <a:sym typeface="Calibri"/>
-              </a:rPr>
-              <a:t>You need to save the file in PDF and upload the same on portal. No PPT, Word Doc or any other format will be supported.</a:t>
-            </a:r>
-            <a:endParaRPr lang="en-US" b="1" dirty="0">
-              <a:latin typeface="Arial" panose="020B0604020202020204" pitchFamily="34" charset="0"/>
-              <a:cs typeface="Arial" panose="020B0604020202020204" pitchFamily="34" charset="0"/>
-            </a:endParaRPr>
-          </a:p>
-          <a:p>
-            <a:pPr marL="514350" marR="0" lvl="0" indent="-349885" algn="just" rtl="0">
-              <a:lnSpc>
-                <a:spcPct val="90000"/>
-              </a:lnSpc>
-              <a:spcBef>
-                <a:spcPts val="1000"/>
-              </a:spcBef>
-              <a:spcAft>
-                <a:spcPts val="0"/>
-              </a:spcAft>
-              <a:buClr>
-                <a:schemeClr val="dk1"/>
-              </a:buClr>
-              <a:buSzPct val="100000"/>
-              <a:buFont typeface="Calibri"/>
-              <a:buNone/>
-            </a:pPr>
-            <a:endParaRPr lang="en-US" b="1" i="0" u="none" strike="noStrike" cap="none" dirty="0">
-              <a:solidFill>
-                <a:schemeClr val="dk1"/>
-              </a:solidFill>
-              <a:latin typeface="Arial" panose="020B0604020202020204" pitchFamily="34" charset="0"/>
-              <a:ea typeface="Calibri"/>
-              <a:cs typeface="Arial" panose="020B0604020202020204" pitchFamily="34" charset="0"/>
-              <a:sym typeface="Calibri"/>
-            </a:endParaRPr>
-          </a:p>
-          <a:p>
-            <a:pPr marL="0" marR="0" lvl="0" indent="0" algn="just" rtl="0">
-              <a:lnSpc>
-                <a:spcPct val="90000"/>
-              </a:lnSpc>
-              <a:spcBef>
-                <a:spcPts val="1000"/>
-              </a:spcBef>
-              <a:spcAft>
-                <a:spcPts val="0"/>
-              </a:spcAft>
-              <a:buClr>
-                <a:schemeClr val="dk1"/>
-              </a:buClr>
-              <a:buSzPct val="100000"/>
-              <a:buFont typeface="Arial"/>
-              <a:buNone/>
-            </a:pPr>
-            <a:r>
-              <a:rPr lang="en-US" b="1" i="0" u="none" strike="noStrike" cap="none" dirty="0">
-                <a:solidFill>
-                  <a:srgbClr val="C00000"/>
-                </a:solidFill>
-                <a:latin typeface="Arial" panose="020B0604020202020204" pitchFamily="34" charset="0"/>
-                <a:ea typeface="Calibri"/>
-                <a:cs typeface="Arial" panose="020B0604020202020204" pitchFamily="34" charset="0"/>
-                <a:sym typeface="Calibri"/>
-              </a:rPr>
-              <a:t>Note - You can delete this slide (Important Pointers) when you upload the details of your idea portal.</a:t>
-            </a:r>
-            <a:endParaRPr lang="en-US" b="1" dirty="0">
-              <a:solidFill>
-                <a:srgbClr val="C00000"/>
-              </a:solidFill>
-              <a:latin typeface="Arial" panose="020B0604020202020204" pitchFamily="34" charset="0"/>
-              <a:cs typeface="Arial" panose="020B0604020202020204" pitchFamily="34" charset="0"/>
-            </a:endParaRPr>
-          </a:p>
-          <a:p>
-            <a:pPr marL="914400" marR="0" lvl="1" indent="-316230" algn="just" rtl="0">
-              <a:lnSpc>
-                <a:spcPct val="90000"/>
-              </a:lnSpc>
-              <a:spcBef>
-                <a:spcPts val="500"/>
-              </a:spcBef>
-              <a:spcAft>
-                <a:spcPts val="0"/>
-              </a:spcAft>
-              <a:buClr>
-                <a:schemeClr val="dk1"/>
-              </a:buClr>
-              <a:buSzPct val="100000"/>
-              <a:buFont typeface="Calibri"/>
-              <a:buNone/>
-            </a:pPr>
-            <a:endParaRPr lang="en-US" sz="2000" b="1" i="0" u="none" strike="noStrike" cap="none" dirty="0">
-              <a:solidFill>
-                <a:schemeClr val="dk1"/>
-              </a:solidFill>
-              <a:latin typeface="Arial" panose="020B0604020202020204" pitchFamily="34" charset="0"/>
-              <a:ea typeface="Calibri"/>
-              <a:cs typeface="Arial" panose="020B0604020202020204" pitchFamily="34" charset="0"/>
-              <a:sym typeface="Calibri"/>
-            </a:endParaRPr>
+              <a:defRPr sz="1800" b="1">
+                <a:latin typeface="Arial"/>
+              </a:defRPr>
+            </a:pPr>
+            <a:r>
+              <a:t>Student Name: Gaurav Jain (Registered on portal)</a:t>
+            </a:r>
+          </a:p>
+          <a:p>
+            <a:pPr>
+              <a:defRPr sz="1800" b="1">
+                <a:latin typeface="Arial"/>
+              </a:defRPr>
+            </a:pPr>
+            <a:r>
+              <a:t>Student ID: 23BAI10053</a:t>
+            </a:r>
           </a:p>
         </p:txBody>
       </p:sp>
     </p:spTree>
     <p:extLst>
       <p:ext uri="{BB962C8B-B14F-4D97-AF65-F5344CB8AC3E}">
-        <p14:creationId xmlns:p14="http://schemas.microsoft.com/office/powerpoint/2010/main" val="1588084416"/>
+        <p14:creationId xmlns:p14="http://schemas.microsoft.com/office/powerpoint/2010/main" val="3319884780"/>
       </p:ext>
     </p:extLst>
   </p:cSld>
@@ -5596,83 +5119,49 @@
       </p:grpSpPr>
       <p:sp>
         <p:nvSpPr>
-          <p:cNvPr id="4" name="Footer Placeholder 3">
-            <a:extLst>
-              <a:ext uri="{FF2B5EF4-FFF2-40B4-BE49-F238E27FC236}">
-                <a16:creationId xmlns:a16="http://schemas.microsoft.com/office/drawing/2014/main" id="{C2A033A5-F70E-7E73-0B8C-FA62C08DEB56}"/>
-              </a:ext>
-            </a:extLst>
-          </p:cNvPr>
-          <p:cNvSpPr>
-            <a:spLocks noGrp="1"/>
-          </p:cNvSpPr>
-          <p:nvPr>
-            <p:ph type="ftr" sz="quarter" idx="11"/>
-          </p:nvPr>
-        </p:nvSpPr>
-        <p:spPr/>
+          <p:cNvPr id="15361" name="Title 1"/>
+          <p:cNvSpPr>
+            <a:spLocks noGrp="1"/>
+          </p:cNvSpPr>
+          <p:nvPr>
+            <p:ph type="title"/>
+          </p:nvPr>
+        </p:nvSpPr>
+        <p:spPr>
+          <a:xfrm>
+            <a:off x="182998" y="0"/>
+            <a:ext cx="10972800" cy="1143000"/>
+          </a:xfrm>
+        </p:spPr>
         <p:txBody>
           <a:bodyPr/>
           <a:lstStyle/>
           <a:p>
             <a:pPr>
-              <a:defRPr/>
-            </a:pPr>
-            <a:r>
-              <a:rPr lang="en-US"/>
-              <a:t>@SIH Idea submission- Template</a:t>
-            </a:r>
-          </a:p>
-        </p:txBody>
-      </p:sp>
-      <p:sp>
-        <p:nvSpPr>
-          <p:cNvPr id="5" name="Slide Number Placeholder 4">
-            <a:extLst>
-              <a:ext uri="{FF2B5EF4-FFF2-40B4-BE49-F238E27FC236}">
-                <a16:creationId xmlns:a16="http://schemas.microsoft.com/office/drawing/2014/main" id="{EC99EC04-BCF1-5A69-7D5A-95D43C9763A1}"/>
-              </a:ext>
-            </a:extLst>
-          </p:cNvPr>
-          <p:cNvSpPr>
-            <a:spLocks noGrp="1"/>
-          </p:cNvSpPr>
-          <p:nvPr>
-            <p:ph type="sldNum" sz="quarter" idx="12"/>
-          </p:nvPr>
-        </p:nvSpPr>
-        <p:spPr/>
-        <p:txBody>
-          <a:bodyPr/>
-          <a:lstStyle/>
-          <a:p>
-            <a:fld id="{677C3CE7-23F7-4828-823C-E0205DF2CF97}" type="slidenum">
-              <a:rPr lang="en-US" smtClean="0"/>
-              <a:pPr/>
-              <a:t>2</a:t>
-            </a:fld>
-            <a:endParaRPr lang="en-US"/>
-          </a:p>
-        </p:txBody>
-      </p:sp>
-      <p:sp>
-        <p:nvSpPr>
-          <p:cNvPr id="6" name="Subtitle 3">
-            <a:extLst>
-              <a:ext uri="{FF2B5EF4-FFF2-40B4-BE49-F238E27FC236}">
-                <a16:creationId xmlns:a16="http://schemas.microsoft.com/office/drawing/2014/main" id="{E0A8E5C6-6BFC-01E5-DDF5-B6A7738A64F4}"/>
-              </a:ext>
-            </a:extLst>
-          </p:cNvPr>
+              <a:defRPr b="1">
+                <a:solidFill>
+                  <a:srgbClr val="1D4ED8"/>
+                </a:solidFill>
+              </a:defRPr>
+            </a:pPr>
+            <a:r>
+              <a:t>PROPOSED SOLUTION</a:t>
+            </a:r>
+          </a:p>
+        </p:txBody>
+      </p:sp>
+      <p:sp>
+        <p:nvSpPr>
+          <p:cNvPr id="15362" name="TextBox 8"/>
           <p:cNvSpPr txBox="1">
-            <a:spLocks/>
+            <a:spLocks noChangeArrowheads="1"/>
           </p:cNvSpPr>
           <p:nvPr/>
         </p:nvSpPr>
         <p:spPr bwMode="auto">
           <a:xfrm>
-            <a:off x="1415369" y="-365784"/>
-            <a:ext cx="8534400" cy="1752600"/>
+            <a:off x="457200" y="1371600"/>
+            <a:ext cx="5486400" cy="4754880"/>
           </a:xfrm>
           <a:prstGeom prst="rect">
             <a:avLst/>
@@ -5686,314 +5175,193 @@
           </a:ln>
         </p:spPr>
         <p:txBody>
-          <a:bodyPr vert="horz" wrap="square" lIns="91440" tIns="45720" rIns="91440" bIns="45720" numCol="1" anchor="t" anchorCtr="0" compatLnSpc="1">
-            <a:prstTxWarp prst="textNoShape">
-              <a:avLst/>
-            </a:prstTxWarp>
+          <a:bodyPr wrap="square">
+            <a:spAutoFit/>
           </a:bodyPr>
-          <a:lstStyle>
-            <a:lvl1pPr marL="0" indent="0" algn="ctr" defTabSz="457200" rtl="0" eaLnBrk="0" fontAlgn="base" hangingPunct="0">
-              <a:spcBef>
-                <a:spcPct val="20000"/>
-              </a:spcBef>
+          <a:lstStyle/>
+          <a:p>
+            <a:pPr>
               <a:spcAft>
-                <a:spcPct val="0"/>
+                <a:spcPts val="1200"/>
               </a:spcAft>
-              <a:buFont typeface="Arial" pitchFamily="34" charset="0"/>
-              <a:buNone/>
-              <a:defRPr sz="3200" kern="1200">
+              <a:defRPr sz="1800" b="1">
                 <a:solidFill>
-                  <a:schemeClr val="tx1">
-                    <a:tint val="75000"/>
-                  </a:schemeClr>
-                </a:solidFill>
-                <a:latin typeface="TradeGothic"/>
-                <a:ea typeface="ＭＳ Ｐゴシック" charset="0"/>
-                <a:cs typeface="ＭＳ Ｐゴシック" charset="0"/>
-              </a:defRPr>
-            </a:lvl1pPr>
-            <a:lvl2pPr marL="457200" indent="0" algn="ctr" defTabSz="457200" rtl="0" eaLnBrk="0" fontAlgn="base" hangingPunct="0">
-              <a:spcBef>
-                <a:spcPct val="20000"/>
-              </a:spcBef>
-              <a:spcAft>
-                <a:spcPct val="0"/>
-              </a:spcAft>
-              <a:buFont typeface="Arial" pitchFamily="34" charset="0"/>
-              <a:buNone/>
-              <a:defRPr sz="2800" kern="1200">
-                <a:solidFill>
-                  <a:schemeClr val="tx1">
-                    <a:tint val="75000"/>
-                  </a:schemeClr>
-                </a:solidFill>
-                <a:latin typeface="TradeGothic"/>
-                <a:ea typeface="ＭＳ Ｐゴシック" charset="0"/>
-                <a:cs typeface="+mn-cs"/>
-              </a:defRPr>
-            </a:lvl2pPr>
-            <a:lvl3pPr marL="914400" indent="0" algn="ctr" defTabSz="457200" rtl="0" eaLnBrk="0" fontAlgn="base" hangingPunct="0">
-              <a:spcBef>
-                <a:spcPct val="20000"/>
-              </a:spcBef>
-              <a:spcAft>
-                <a:spcPct val="0"/>
-              </a:spcAft>
-              <a:buFont typeface="Arial" pitchFamily="34" charset="0"/>
-              <a:buNone/>
-              <a:defRPr sz="2400" kern="1200">
-                <a:solidFill>
-                  <a:schemeClr val="tx1">
-                    <a:tint val="75000"/>
-                  </a:schemeClr>
-                </a:solidFill>
-                <a:latin typeface="TradeGothic"/>
-                <a:ea typeface="ＭＳ Ｐゴシック" charset="0"/>
-                <a:cs typeface="+mn-cs"/>
-              </a:defRPr>
-            </a:lvl3pPr>
-            <a:lvl4pPr marL="1371600" indent="0" algn="ctr" defTabSz="457200" rtl="0" eaLnBrk="0" fontAlgn="base" hangingPunct="0">
-              <a:spcBef>
-                <a:spcPct val="20000"/>
-              </a:spcBef>
-              <a:spcAft>
-                <a:spcPct val="0"/>
-              </a:spcAft>
-              <a:buFont typeface="Arial" pitchFamily="34" charset="0"/>
-              <a:buNone/>
-              <a:defRPr sz="2000" kern="1200">
-                <a:solidFill>
-                  <a:schemeClr val="tx1">
-                    <a:tint val="75000"/>
-                  </a:schemeClr>
-                </a:solidFill>
-                <a:latin typeface="TradeGothic"/>
-                <a:ea typeface="ＭＳ Ｐゴシック" charset="0"/>
-                <a:cs typeface="+mn-cs"/>
-              </a:defRPr>
-            </a:lvl4pPr>
-            <a:lvl5pPr marL="1828800" indent="0" algn="ctr" defTabSz="457200" rtl="0" eaLnBrk="0" fontAlgn="base" hangingPunct="0">
-              <a:spcBef>
-                <a:spcPct val="20000"/>
-              </a:spcBef>
-              <a:spcAft>
-                <a:spcPct val="0"/>
-              </a:spcAft>
-              <a:buFont typeface="Arial" pitchFamily="34" charset="0"/>
-              <a:buNone/>
-              <a:defRPr sz="2000" kern="1200">
-                <a:solidFill>
-                  <a:schemeClr val="tx1">
-                    <a:tint val="75000"/>
-                  </a:schemeClr>
-                </a:solidFill>
-                <a:latin typeface="TradeGothic"/>
-                <a:ea typeface="ＭＳ Ｐゴシック" charset="0"/>
-                <a:cs typeface="+mn-cs"/>
-              </a:defRPr>
-            </a:lvl5pPr>
-            <a:lvl6pPr marL="2286000" indent="0" algn="ctr" defTabSz="457200" rtl="0" eaLnBrk="1" latinLnBrk="0" hangingPunct="1">
-              <a:spcBef>
-                <a:spcPct val="20000"/>
-              </a:spcBef>
-              <a:buFont typeface="Arial"/>
-              <a:buNone/>
-              <a:defRPr sz="2000" kern="1200">
-                <a:solidFill>
-                  <a:schemeClr val="tx1">
-                    <a:tint val="75000"/>
-                  </a:schemeClr>
-                </a:solidFill>
-                <a:latin typeface="+mn-lt"/>
-                <a:ea typeface="+mn-ea"/>
-                <a:cs typeface="+mn-cs"/>
-              </a:defRPr>
-            </a:lvl6pPr>
-            <a:lvl7pPr marL="2743200" indent="0" algn="ctr" defTabSz="457200" rtl="0" eaLnBrk="1" latinLnBrk="0" hangingPunct="1">
-              <a:spcBef>
-                <a:spcPct val="20000"/>
-              </a:spcBef>
-              <a:buFont typeface="Arial"/>
-              <a:buNone/>
-              <a:defRPr sz="2000" kern="1200">
-                <a:solidFill>
-                  <a:schemeClr val="tx1">
-                    <a:tint val="75000"/>
-                  </a:schemeClr>
-                </a:solidFill>
-                <a:latin typeface="+mn-lt"/>
-                <a:ea typeface="+mn-ea"/>
-                <a:cs typeface="+mn-cs"/>
-              </a:defRPr>
-            </a:lvl7pPr>
-            <a:lvl8pPr marL="3200400" indent="0" algn="ctr" defTabSz="457200" rtl="0" eaLnBrk="1" latinLnBrk="0" hangingPunct="1">
-              <a:spcBef>
-                <a:spcPct val="20000"/>
-              </a:spcBef>
-              <a:buFont typeface="Arial"/>
-              <a:buNone/>
-              <a:defRPr sz="2000" kern="1200">
-                <a:solidFill>
-                  <a:schemeClr val="tx1">
-                    <a:tint val="75000"/>
-                  </a:schemeClr>
-                </a:solidFill>
-                <a:latin typeface="+mn-lt"/>
-                <a:ea typeface="+mn-ea"/>
-                <a:cs typeface="+mn-cs"/>
-              </a:defRPr>
-            </a:lvl8pPr>
-            <a:lvl9pPr marL="3657600" indent="0" algn="ctr" defTabSz="457200" rtl="0" eaLnBrk="1" latinLnBrk="0" hangingPunct="1">
-              <a:spcBef>
-                <a:spcPct val="20000"/>
-              </a:spcBef>
-              <a:buFont typeface="Arial"/>
-              <a:buNone/>
-              <a:defRPr sz="2000" kern="1200">
-                <a:solidFill>
-                  <a:schemeClr val="tx1">
-                    <a:tint val="75000"/>
-                  </a:schemeClr>
-                </a:solidFill>
-                <a:latin typeface="+mn-lt"/>
-                <a:ea typeface="+mn-ea"/>
-                <a:cs typeface="+mn-cs"/>
-              </a:defRPr>
-            </a:lvl9pPr>
-          </a:lstStyle>
-          <a:p>
-            <a:pPr>
-              <a:defRPr b="1" sz="2800">
-                <a:solidFill>
-                  <a:srgbClr val="1D4ED8"/>
+                  <a:srgbClr val="1E293B"/>
                 </a:solidFill>
                 <a:latin typeface="Arial"/>
               </a:defRPr>
             </a:pPr>
             <a:r>
-              <a:t>AUTONOMOUS CHOKE CONTROLLER FOR AN OIL WELL</a:t>
-            </a:r>
+              <a:t>AI-Driven Autonomous Choke Control</a:t>
+            </a:r>
+            <a:endParaRPr lang="en-US" sz="3200" u="sng" dirty="0">
+              <a:latin typeface="Arial" pitchFamily="34" charset="0"/>
+              <a:cs typeface="Arial" pitchFamily="34" charset="0"/>
+            </a:endParaRPr>
+          </a:p>
+          <a:p>
+            <a:pPr>
+              <a:spcAft>
+                <a:spcPts val="800"/>
+              </a:spcAft>
+              <a:defRPr sz="1250">
+                <a:latin typeface="Arial"/>
+              </a:defRPr>
+            </a:pPr>
+            <a:r>
+              <a:t>• Concept: Develops an Autonomous Production Choke Controller that automatically regulates choke opening (%) to track target production rates.</a:t>
+            </a:r>
+          </a:p>
+          <a:p>
+            <a:pPr>
+              <a:spcAft>
+                <a:spcPts val="800"/>
+              </a:spcAft>
+              <a:defRPr sz="1250">
+                <a:latin typeface="Arial"/>
+              </a:defRPr>
+            </a:pPr>
+            <a:r>
+              <a:t>• Safe Operating Envelope: Prevents violations of key pressure constraints: Wellhead Pressure (WHP &gt;= 220 psi), Flowline Pressure (FLP &gt;= 150 psi), and Bottom Hole Pressure (BHP &gt;= 2900 psi).</a:t>
+            </a:r>
+          </a:p>
+          <a:p>
+            <a:pPr>
+              <a:spcAft>
+                <a:spcPts val="800"/>
+              </a:spcAft>
+              <a:defRPr sz="1250">
+                <a:latin typeface="Arial"/>
+              </a:defRPr>
+            </a:pPr>
+            <a:r>
+              <a:t>• Control Algorithm: Implements Model Predictive Control (MPC) using a candidate-evaluation approach (brute-force evaluation of 101 candidates per step).</a:t>
+            </a:r>
+          </a:p>
+          <a:p>
+            <a:pPr>
+              <a:spcAft>
+                <a:spcPts val="800"/>
+              </a:spcAft>
+              <a:defRPr sz="1250">
+                <a:latin typeface="Arial"/>
+              </a:defRPr>
+            </a:pPr>
+            <a:r>
+              <a:t>• Long Horizon: Uses a 30-hour prediction horizon to anticipate slow BHP dynamics (tau ~ 13.5h), rejecting choke moves that cause future pressure violations.</a:t>
+            </a:r>
+          </a:p>
+          <a:p>
+            <a:pPr>
+              <a:spcAft>
+                <a:spcPts val="800"/>
+              </a:spcAft>
+              <a:defRPr sz="1250">
+                <a:latin typeface="Arial"/>
+              </a:defRPr>
+            </a:pPr>
+            <a:r>
+              <a:t>• Steady-State Optimality: If the target is infeasible, it automatically settles on the boundary of the safe operating envelope, maximizing safe production.</a:t>
+            </a:r>
+          </a:p>
+        </p:txBody>
+      </p:sp>
+      <p:sp>
+        <p:nvSpPr>
+          <p:cNvPr id="6" name="Slide Number Placeholder 5"/>
+          <p:cNvSpPr>
+            <a:spLocks noGrp="1"/>
+          </p:cNvSpPr>
+          <p:nvPr>
+            <p:ph type="sldNum" sz="quarter" idx="12"/>
+          </p:nvPr>
+        </p:nvSpPr>
+        <p:spPr/>
+        <p:txBody>
+          <a:bodyPr/>
+          <a:lstStyle/>
+          <a:p>
+            <a:fld id="{677C3CE7-23F7-4828-823C-E0205DF2CF97}" type="slidenum">
+              <a:rPr lang="en-US" b="1" smtClean="0">
+                <a:solidFill>
+                  <a:schemeClr val="bg1"/>
+                </a:solidFill>
+              </a:rPr>
+              <a:pPr/>
+              <a:t>2</a:t>
+            </a:fld>
             <a:endParaRPr lang="en-US" b="1" dirty="0">
               <a:solidFill>
-                <a:schemeClr val="tx1"/>
+                <a:schemeClr val="bg1"/>
               </a:solidFill>
-              <a:latin typeface="Times New Roman" panose="02020603050405020304" pitchFamily="18" charset="0"/>
-              <a:cs typeface="Times New Roman" panose="02020603050405020304" pitchFamily="18" charset="0"/>
             </a:endParaRPr>
           </a:p>
         </p:txBody>
       </p:sp>
       <p:sp>
         <p:nvSpPr>
-          <p:cNvPr id="7" name="TextBox 6">
-            <a:extLst>
-              <a:ext uri="{FF2B5EF4-FFF2-40B4-BE49-F238E27FC236}">
-                <a16:creationId xmlns:a16="http://schemas.microsoft.com/office/drawing/2014/main" id="{AFB1BDE7-2DA0-F526-CF6E-F50D43C2C5FE}"/>
-              </a:ext>
-            </a:extLst>
-          </p:cNvPr>
-          <p:cNvSpPr txBox="1"/>
-          <p:nvPr/>
+          <p:cNvPr id="7" name="Footer Placeholder 6"/>
+          <p:cNvSpPr>
+            <a:spLocks noGrp="1"/>
+          </p:cNvSpPr>
+          <p:nvPr>
+            <p:ph type="ftr" sz="quarter" idx="11"/>
+          </p:nvPr>
         </p:nvSpPr>
         <p:spPr>
           <a:xfrm>
-            <a:off x="397274" y="1203454"/>
-            <a:ext cx="5924550" cy="4686668"/>
+            <a:off x="4648200" y="6356353"/>
+            <a:ext cx="3204000" cy="365125"/>
+          </a:xfrm>
+        </p:spPr>
+        <p:txBody>
+          <a:bodyPr/>
+          <a:lstStyle/>
+          <a:p>
+            <a:pPr>
+              <a:defRPr/>
+            </a:pPr>
+            <a:r>
+              <a:rPr lang="en-US">
+                <a:solidFill>
+                  <a:schemeClr val="bg1"/>
+                </a:solidFill>
+              </a:rPr>
+              <a:t>@SIH Idea submission- Template</a:t>
+            </a:r>
+            <a:endParaRPr lang="en-US" dirty="0">
+              <a:solidFill>
+                <a:schemeClr val="bg1"/>
+              </a:solidFill>
+            </a:endParaRPr>
+          </a:p>
+        </p:txBody>
+      </p:sp>
+      <p:pic>
+        <p:nvPicPr>
+          <p:cNvPr id="15363" name="Picture 15362" descr="open_loop_step_test.png"/>
+          <p:cNvPicPr>
+            <a:picLocks noChangeAspect="1"/>
+          </p:cNvPicPr>
+          <p:nvPr/>
+        </p:nvPicPr>
+        <p:blipFill>
+          <a:blip r:embed="rId3"/>
+          <a:stretch>
+            <a:fillRect/>
+          </a:stretch>
+        </p:blipFill>
+        <p:spPr>
+          <a:xfrm>
+            <a:off x="6217920" y="1371600"/>
+            <a:ext cx="5486400" cy="4389120"/>
           </a:xfrm>
           <a:prstGeom prst="rect">
             <a:avLst/>
           </a:prstGeom>
-          <a:noFill/>
         </p:spPr>
-        <p:txBody>
-          <a:bodyPr wrap="square" rtlCol="0">
-            <a:spAutoFit/>
-          </a:bodyPr>
-          <a:lstStyle/>
-          <a:p>
-            <a:pPr>
-              <a:spcAft>
-                <a:spcPts val="800"/>
-              </a:spcAft>
-              <a:defRPr sz="1800">
-                <a:latin typeface="Arial"/>
-              </a:defRPr>
-            </a:pPr>
-            <a:r>
-              <a:t>Problem Statement ID: SIH1747</a:t>
-            </a:r>
-            <a:endParaRPr lang="en-US" dirty="0"/>
-          </a:p>
-          <a:p>
-            <a:pPr>
-              <a:spcAft>
-                <a:spcPts val="800"/>
-              </a:spcAft>
-              <a:defRPr b="1" sz="1800">
-                <a:latin typeface="Arial"/>
-              </a:defRPr>
-            </a:pPr>
-            <a:r>
-              <a:t>Problem Statement Title: Autonomous Choke Control for a Single Naturally Flowing Oil Well</a:t>
-            </a:r>
-          </a:p>
-          <a:p>
-            <a:pPr>
-              <a:spcAft>
-                <a:spcPts val="800"/>
-              </a:spcAft>
-              <a:defRPr sz="1800">
-                <a:latin typeface="Arial"/>
-              </a:defRPr>
-            </a:pPr>
-            <a:r>
-              <a:t>Theme: Smart Automation &amp; Energy Systems</a:t>
-            </a:r>
-          </a:p>
-          <a:p>
-            <a:pPr>
-              <a:spcAft>
-                <a:spcPts val="1600"/>
-              </a:spcAft>
-              <a:defRPr sz="1800">
-                <a:latin typeface="Arial"/>
-              </a:defRPr>
-            </a:pPr>
-            <a:r>
-              <a:t>PS Category: Software / Algorithm</a:t>
-            </a:r>
-          </a:p>
-          <a:p>
-            <a:pPr>
-              <a:spcAft>
-                <a:spcPts val="800"/>
-              </a:spcAft>
-              <a:defRPr b="1" sz="1800">
-                <a:latin typeface="Arial"/>
-              </a:defRPr>
-            </a:pPr>
-            <a:r>
-              <a:t>Student Name: Gaurav Jain (Registered on portal)</a:t>
-            </a:r>
-          </a:p>
-          <a:p>
-            <a:pPr>
-              <a:defRPr b="1" sz="1800">
-                <a:latin typeface="Arial"/>
-              </a:defRPr>
-            </a:pPr>
-            <a:r>
-              <a:t>Student ID: 23BAI10053</a:t>
-            </a:r>
-          </a:p>
-        </p:txBody>
-      </p:sp>
+      </p:pic>
     </p:spTree>
-    <p:extLst>
-      <p:ext uri="{BB962C8B-B14F-4D97-AF65-F5344CB8AC3E}">
-        <p14:creationId xmlns:p14="http://schemas.microsoft.com/office/powerpoint/2010/main" val="3319884780"/>
-      </p:ext>
-    </p:extLst>
   </p:cSld>
   <p:clrMapOvr>
     <a:masterClrMapping/>
@@ -6020,7 +5388,7 @@
       </p:grpSpPr>
       <p:sp>
         <p:nvSpPr>
-          <p:cNvPr id="15361" name="Title 1"/>
+          <p:cNvPr id="17409" name="Title 1"/>
           <p:cNvSpPr>
             <a:spLocks noGrp="1"/>
           </p:cNvSpPr>
@@ -6028,12 +5396,7 @@
             <p:ph type="title"/>
           </p:nvPr>
         </p:nvSpPr>
-        <p:spPr>
-          <a:xfrm>
-            <a:off x="182998" y="0"/>
-            <a:ext cx="10972800" cy="1143000"/>
-          </a:xfrm>
-        </p:spPr>
+        <p:spPr/>
         <p:txBody>
           <a:bodyPr/>
           <a:lstStyle/>
@@ -6046,14 +5409,14 @@
               </a:defRPr>
             </a:pPr>
             <a:r>
-              <a:t>PROPOSED SOLUTION</a:t>
-            </a:r>
-          </a:p>
-        </p:txBody>
-      </p:sp>
-      <p:sp>
-        <p:nvSpPr>
-          <p:cNvPr id="15362" name="TextBox 8"/>
+              <a:t>TECHNICAL APPROACH &amp; DYNAMIC MODEL</a:t>
+            </a:r>
+          </a:p>
+        </p:txBody>
+      </p:sp>
+      <p:sp>
+        <p:nvSpPr>
+          <p:cNvPr id="17410" name="TextBox 8"/>
           <p:cNvSpPr txBox="1">
             <a:spLocks noChangeArrowheads="1"/>
           </p:cNvSpPr>
@@ -6081,10 +5444,12 @@
           </a:bodyPr>
           <a:lstStyle/>
           <a:p>
-            <a:pPr>
+            <a:pPr marL="342900" indent="-342900" algn="just">
               <a:spcAft>
                 <a:spcPts val="1200"/>
               </a:spcAft>
+              <a:buFont typeface="Arial" panose="020B0604020202020204" pitchFamily="34" charset="0"/>
+              <a:buChar char="•"/>
               <a:defRPr sz="1800" b="1">
                 <a:solidFill>
                   <a:srgbClr val="1E293B"/>
@@ -6093,24 +5458,20 @@
               </a:defRPr>
             </a:pPr>
             <a:r>
-              <a:t>AI-Driven Autonomous Choke Control</a:t>
-            </a:r>
-            <a:endParaRPr lang="en-US" sz="3200" u="sng" dirty="0">
-              <a:latin typeface="Arial" pitchFamily="34" charset="0"/>
-              <a:cs typeface="Arial" pitchFamily="34" charset="0"/>
-            </a:endParaRPr>
+              <a:t>System Modeling &amp; Optimization</a:t>
+            </a:r>
           </a:p>
           <a:p>
             <a:pPr>
               <a:spcAft>
                 <a:spcPts val="800"/>
               </a:spcAft>
-              <a:defRPr sz="1250">
+              <a:defRPr sz="1100">
                 <a:latin typeface="Arial"/>
               </a:defRPr>
             </a:pPr>
             <a:r>
-              <a:t>• Concept: Develops an Autonomous Production Choke Controller that automatically regulates choke opening (%) to track target production rates.</a:t>
+              <a:t>• System Modeling: Process dynamics are identified as decoupled first-order Autoregressive with Exogenous input (ARX) models from open-loop step test data:</a:t>
             </a:r>
           </a:p>
           <a:p>
@@ -6118,12 +5479,12 @@
               <a:spcAft>
                 <a:spcPts val="800"/>
               </a:spcAft>
-              <a:defRPr sz="1250">
+              <a:defRPr sz="1100">
                 <a:latin typeface="Arial"/>
               </a:defRPr>
             </a:pPr>
             <a:r>
-              <a:t>• Safe Operating Envelope: Prevents violations of key pressure constraints: Wellhead Pressure (WHP &gt;= 220 psi), Flowline Pressure (FLP &gt;= 150 psi), and Bottom Hole Pressure (BHP &gt;= 2900 psi).</a:t>
+              <a:t>  - Oil Rate Q(t) = 0.8237*Q(t-1) + 0.3201*u(t-1) + 6.932 (Gain: +1.815 bbl/hr/%)</a:t>
             </a:r>
           </a:p>
           <a:p>
@@ -6131,12 +5492,12 @@
               <a:spcAft>
                 <a:spcPts val="800"/>
               </a:spcAft>
-              <a:defRPr sz="1250">
+              <a:defRPr sz="1100">
                 <a:latin typeface="Arial"/>
               </a:defRPr>
             </a:pPr>
             <a:r>
-              <a:t>• Control Algorithm: Implements Model Predictive Control (MPC) using a candidate-evaluation approach (brute-force evaluation of 101 candidates per step).</a:t>
+              <a:t>  - WHP(t) = 0.8892*WHP(t-1) - 0.1756*u(t-1) + 35.376 (Gain: -1.586 psi/%)</a:t>
             </a:r>
           </a:p>
           <a:p>
@@ -6144,12 +5505,12 @@
               <a:spcAft>
                 <a:spcPts val="800"/>
               </a:spcAft>
-              <a:defRPr sz="1250">
+              <a:defRPr sz="1100">
                 <a:latin typeface="Arial"/>
               </a:defRPr>
             </a:pPr>
             <a:r>
-              <a:t>• Long Horizon: Uses a 30-hour prediction horizon to anticipate slow BHP dynamics (tau ~ 13.5h), rejecting choke moves that cause future pressure violations.</a:t>
+              <a:t>  - FLP(t) = 0.8625*FLP(t-1) - 0.1356*u(t-1) + 30.143 (Gain: -0.986 psi/%)</a:t>
             </a:r>
           </a:p>
           <a:p>
@@ -6157,12 +5518,38 @@
               <a:spcAft>
                 <a:spcPts val="800"/>
               </a:spcAft>
-              <a:defRPr sz="1250">
+              <a:defRPr sz="1100">
                 <a:latin typeface="Arial"/>
               </a:defRPr>
             </a:pPr>
             <a:r>
-              <a:t>• Steady-State Optimality: If the target is infeasible, it automatically settles on the boundary of the safe operating envelope, maximizing safe production.</a:t>
+              <a:t>  - BHP(t) = 0.9257*BHP(t-1) - 0.6225*u(t-1) + 253.761 (Gain: -8.383 psi/%)</a:t>
+            </a:r>
+          </a:p>
+          <a:p>
+            <a:pPr>
+              <a:spcAft>
+                <a:spcPts val="800"/>
+              </a:spcAft>
+              <a:defRPr sz="1100">
+                <a:latin typeface="Arial"/>
+              </a:defRPr>
+            </a:pPr>
+            <a:r>
+              <a:t>• Choke Constraints: Max ramp rate of +/- 5% choke opening per hour is strictly enforced by the candidate set boundaries.</a:t>
+            </a:r>
+          </a:p>
+          <a:p>
+            <a:pPr>
+              <a:spcAft>
+                <a:spcPts val="800"/>
+              </a:spcAft>
+              <a:defRPr sz="1100">
+                <a:latin typeface="Arial"/>
+              </a:defRPr>
+            </a:pPr>
+            <a:r>
+              <a:t>• Cost Optimization: Evaluates 101 choke trajectories and optimizes tracking error while penalizing constraint violations by a factor of 1e6.</a:t>
             </a:r>
           </a:p>
         </p:txBody>
@@ -6183,7 +5570,7 @@
           <a:lstStyle/>
           <a:p>
             <a:fld id="{677C3CE7-23F7-4828-823C-E0205DF2CF97}" type="slidenum">
-              <a:rPr lang="en-US" b="1" smtClean="0">
+              <a:rPr lang="en-US" b="1">
                 <a:solidFill>
                   <a:schemeClr val="bg1"/>
                 </a:solidFill>
@@ -6240,7 +5627,7 @@
       </p:sp>
       <p:pic>
         <p:nvPicPr>
-          <p:cNvPr id="15363" name="Picture 15362" descr="open_loop_step_test.png"/>
+          <p:cNvPr id="17411" name="Picture 17410" descr="scenario_a_startup.png"/>
           <p:cNvPicPr>
             <a:picLocks noChangeAspect="1"/>
           </p:cNvPicPr>
@@ -6310,7 +5697,7 @@
               </a:defRPr>
             </a:pPr>
             <a:r>
-              <a:t>TECHNICAL APPROACH &amp; DYNAMIC MODEL</a:t>
+              <a:t>FEASIBILITY, VIABILITY &amp; SAFETY</a:t>
             </a:r>
           </a:p>
         </p:txBody>
@@ -6345,12 +5732,21 @@
           </a:bodyPr>
           <a:lstStyle/>
           <a:p>
-            <a:pPr marL="342900" indent="-342900" algn="just">
+            <a:pPr marL="342900" marR="0" lvl="0" indent="-342900" algn="just" defTabSz="457200" rtl="0" eaLnBrk="1" fontAlgn="base" latinLnBrk="0" hangingPunct="1">
+              <a:lnSpc>
+                <a:spcPct val="100000"/>
+              </a:lnSpc>
+              <a:spcBef>
+                <a:spcPct val="0"/>
+              </a:spcBef>
               <a:spcAft>
                 <a:spcPts val="1200"/>
               </a:spcAft>
+              <a:buClrTx/>
+              <a:buSzTx/>
               <a:buFont typeface="Arial" panose="020B0604020202020204" pitchFamily="34" charset="0"/>
               <a:buChar char="•"/>
+              <a:tabLst/>
               <a:defRPr sz="1800" b="1">
                 <a:solidFill>
                   <a:srgbClr val="1E293B"/>
@@ -6359,20 +5755,34 @@
               </a:defRPr>
             </a:pPr>
             <a:r>
-              <a:t>System Modeling &amp; Optimization</a:t>
-            </a:r>
+              <a:t>Safety Envelope &amp; Feasibility Analysis</a:t>
+            </a:r>
+            <a:endParaRPr kumimoji="0" lang="en-US" sz="2800" b="0" i="0" u="none" strike="noStrike" kern="1200" cap="none" spc="0" normalizeH="0" baseline="0" noProof="0" dirty="0">
+              <a:ln>
+                <a:noFill/>
+              </a:ln>
+              <a:solidFill>
+                <a:prstClr val="black"/>
+              </a:solidFill>
+              <a:effectLst/>
+              <a:uLnTx/>
+              <a:uFillTx/>
+              <a:latin typeface="Arial" pitchFamily="34" charset="0"/>
+              <a:ea typeface="ＭＳ Ｐゴシック" pitchFamily="1" charset="-128"/>
+              <a:cs typeface="Arial" pitchFamily="34" charset="0"/>
+            </a:endParaRPr>
           </a:p>
           <a:p>
             <a:pPr>
               <a:spcAft>
                 <a:spcPts val="800"/>
               </a:spcAft>
-              <a:defRPr sz="1100">
+              <a:defRPr sz="1250">
                 <a:latin typeface="Arial"/>
               </a:defRPr>
             </a:pPr>
             <a:r>
-              <a:t>• System Modeling: Process dynamics are identified as decoupled first-order Autoregressive with Exogenous input (ARX) models from open-loop step test data:</a:t>
+              <a:t>• Low Computational Cost: Evaluating 101 candidate trajectories takes &lt; 10 ms on standard industrial edge compute modules (e.g. Raspberry Pi, Siemens IOT2050, or DCS). No optimization solver library is required.</a:t>
             </a:r>
           </a:p>
           <a:p>
@@ -6380,12 +5790,12 @@
               <a:spcAft>
                 <a:spcPts val="800"/>
               </a:spcAft>
-              <a:defRPr sz="1100">
+              <a:defRPr sz="1250">
                 <a:latin typeface="Arial"/>
               </a:defRPr>
             </a:pPr>
             <a:r>
-              <a:t>  - Oil Rate Q(t) = 0.8237*Q(t-1) + 0.3201*u(t-1) + 6.932 (Gain: +1.815 bbl/hr/%)</a:t>
+              <a:t>• Process Safety Envelope: Safety constraints are verified over the prediction horizon Hp = 30h. Unsafe choke openings are blocked.</a:t>
             </a:r>
           </a:p>
           <a:p>
@@ -6393,12 +5803,12 @@
               <a:spcAft>
                 <a:spcPts val="800"/>
               </a:spcAft>
-              <a:defRPr sz="1100">
+              <a:defRPr sz="1250">
                 <a:latin typeface="Arial"/>
               </a:defRPr>
             </a:pPr>
             <a:r>
-              <a:t>  - WHP(t) = 0.8892*WHP(t-1) - 0.1756*u(t-1) + 35.376 (Gain: -1.586 psi/%)</a:t>
+              <a:t>• Process Noise Tolerance: Uses deterministic ARX equations for predictive models while successfully handling process noise (Q_sigma = 0.73, BHP_sigma = 2.91) in actual operations.</a:t>
             </a:r>
           </a:p>
           <a:p>
@@ -6406,51 +5816,12 @@
               <a:spcAft>
                 <a:spcPts val="800"/>
               </a:spcAft>
-              <a:defRPr sz="1100">
+              <a:defRPr sz="1250">
                 <a:latin typeface="Arial"/>
               </a:defRPr>
             </a:pPr>
             <a:r>
-              <a:t>  - FLP(t) = 0.8625*FLP(t-1) - 0.1356*u(t-1) + 30.143 (Gain: -0.986 psi/%)</a:t>
-            </a:r>
-          </a:p>
-          <a:p>
-            <a:pPr>
-              <a:spcAft>
-                <a:spcPts val="800"/>
-              </a:spcAft>
-              <a:defRPr sz="1100">
-                <a:latin typeface="Arial"/>
-              </a:defRPr>
-            </a:pPr>
-            <a:r>
-              <a:t>  - BHP(t) = 0.9257*BHP(t-1) - 0.6225*u(t-1) + 253.761 (Gain: -8.383 psi/%)</a:t>
-            </a:r>
-          </a:p>
-          <a:p>
-            <a:pPr>
-              <a:spcAft>
-                <a:spcPts val="800"/>
-              </a:spcAft>
-              <a:defRPr sz="1100">
-                <a:latin typeface="Arial"/>
-              </a:defRPr>
-            </a:pPr>
-            <a:r>
-              <a:t>• Choke Constraints: Max ramp rate of +/- 5% choke opening per hour is strictly enforced by the candidate set boundaries.</a:t>
-            </a:r>
-          </a:p>
-          <a:p>
-            <a:pPr>
-              <a:spcAft>
-                <a:spcPts val="800"/>
-              </a:spcAft>
-              <a:defRPr sz="1100">
-                <a:latin typeface="Arial"/>
-              </a:defRPr>
-            </a:pPr>
-            <a:r>
-              <a:t>• Cost Optimization: Evaluates 101 choke trajectories and optimizes tracking error while penalizing constraint violations by a factor of 1e6.</a:t>
+              <a:t>• Economic Value: Maximizes production by safely tracking target rate, or backing off to maximum safe rate when targets are infeasible.</a:t>
             </a:r>
           </a:p>
         </p:txBody>
@@ -6470,19 +5841,70 @@
           <a:bodyPr/>
           <a:lstStyle/>
           <a:p>
+            <a:pPr marL="0" marR="0" lvl="0" indent="0" algn="r" defTabSz="457200" rtl="0" eaLnBrk="1" fontAlgn="base" latinLnBrk="0" hangingPunct="1">
+              <a:lnSpc>
+                <a:spcPct val="100000"/>
+              </a:lnSpc>
+              <a:spcBef>
+                <a:spcPct val="0"/>
+              </a:spcBef>
+              <a:spcAft>
+                <a:spcPct val="0"/>
+              </a:spcAft>
+              <a:buClrTx/>
+              <a:buSzTx/>
+              <a:buFontTx/>
+              <a:buNone/>
+              <a:tabLst/>
+              <a:defRPr/>
+            </a:pPr>
             <a:fld id="{677C3CE7-23F7-4828-823C-E0205DF2CF97}" type="slidenum">
-              <a:rPr lang="en-US" b="1">
+              <a:rPr kumimoji="0" lang="en-US" sz="1200" b="1" i="0" u="none" strike="noStrike" kern="1200" cap="none" spc="0" normalizeH="0" baseline="0" noProof="0">
+                <a:ln>
+                  <a:noFill/>
+                </a:ln>
                 <a:solidFill>
-                  <a:schemeClr val="bg1"/>
+                  <a:prstClr val="white"/>
                 </a:solidFill>
+                <a:effectLst/>
+                <a:uLnTx/>
+                <a:uFillTx/>
+                <a:latin typeface="TradeGothic" pitchFamily="1" charset="0"/>
+                <a:ea typeface="ＭＳ Ｐゴシック" pitchFamily="1" charset="-128"/>
+                <a:cs typeface="+mn-cs"/>
               </a:rPr>
-              <a:pPr/>
+              <a:pPr marL="0" marR="0" lvl="0" indent="0" algn="r" defTabSz="457200" rtl="0" eaLnBrk="1" fontAlgn="base" latinLnBrk="0" hangingPunct="1">
+                <a:lnSpc>
+                  <a:spcPct val="100000"/>
+                </a:lnSpc>
+                <a:spcBef>
+                  <a:spcPct val="0"/>
+                </a:spcBef>
+                <a:spcAft>
+                  <a:spcPct val="0"/>
+                </a:spcAft>
+                <a:buClrTx/>
+                <a:buSzTx/>
+                <a:buFontTx/>
+                <a:buNone/>
+                <a:tabLst/>
+                <a:defRPr/>
+              </a:pPr>
               <a:t>4</a:t>
             </a:fld>
-            <a:endParaRPr lang="en-US" b="1" dirty="0">
+            <a:endParaRPr kumimoji="0" lang="en-US" sz="1200" b="1" i="0" u="none" strike="noStrike" kern="1200" cap="none" spc="0" normalizeH="0" baseline="0" noProof="0" dirty="0">
+              <a:ln>
+                <a:noFill/>
+              </a:ln>
               <a:solidFill>
-                <a:schemeClr val="bg1"/>
+                <a:prstClr val="white"/>
               </a:solidFill>
+              <a:effectLst/>
+              <a:uLnTx/>
+              <a:uFillTx/>
+              <a:latin typeface="TradeGothic" pitchFamily="1" charset="0"/>
+              <a:ea typeface="ＭＳ Ｐゴシック" pitchFamily="1" charset="-128"/>
+              <a:cs typeface="+mn-cs"/>
             </a:endParaRPr>
           </a:p>
         </p:txBody>
@@ -6507,28 +5929,60 @@
           <a:bodyPr/>
           <a:lstStyle/>
           <a:p>
-            <a:pPr>
+            <a:pPr marL="0" marR="0" lvl="0" indent="0" algn="ctr" defTabSz="457200" rtl="0" eaLnBrk="1" fontAlgn="auto" latinLnBrk="0" hangingPunct="1">
+              <a:lnSpc>
+                <a:spcPct val="100000"/>
+              </a:lnSpc>
+              <a:spcBef>
+                <a:spcPts val="0"/>
+              </a:spcBef>
+              <a:spcAft>
+                <a:spcPts val="0"/>
+              </a:spcAft>
+              <a:buClrTx/>
+              <a:buSzTx/>
+              <a:buFontTx/>
+              <a:buNone/>
+              <a:tabLst/>
               <a:defRPr/>
             </a:pPr>
             <a:r>
-              <a:rPr lang="en-US">
+              <a:rPr kumimoji="0" lang="en-US" sz="1200" b="0" i="0" u="none" strike="noStrike" kern="1200" cap="none" spc="0" normalizeH="0" baseline="0" noProof="0">
+                <a:ln>
+                  <a:noFill/>
+                </a:ln>
                 <a:solidFill>
-                  <a:schemeClr val="bg1"/>
+                  <a:prstClr val="white"/>
                 </a:solidFill>
+                <a:effectLst/>
+                <a:uLnTx/>
+                <a:uFillTx/>
+                <a:latin typeface="TradeGothic"/>
+                <a:ea typeface="+mn-ea"/>
+                <a:cs typeface="+mn-cs"/>
               </a:rPr>
               <a:t>@SIH Idea submission- Template</a:t>
             </a:r>
-            <a:endParaRPr lang="en-US" dirty="0">
+            <a:endParaRPr kumimoji="0" lang="en-US" sz="1200" b="0" i="0" u="none" strike="noStrike" kern="1200" cap="none" spc="0" normalizeH="0" baseline="0" noProof="0" dirty="0">
+              <a:ln>
+                <a:noFill/>
+              </a:ln>
               <a:solidFill>
-                <a:schemeClr val="bg1"/>
+                <a:prstClr val="white"/>
               </a:solidFill>
+              <a:effectLst/>
+              <a:uLnTx/>
+              <a:uFillTx/>
+              <a:latin typeface="TradeGothic"/>
+              <a:ea typeface="+mn-ea"/>
+              <a:cs typeface="+mn-cs"/>
             </a:endParaRPr>
           </a:p>
         </p:txBody>
       </p:sp>
       <p:pic>
         <p:nvPicPr>
-          <p:cNvPr id="17411" name="Picture 17410" descr="scenario_a_startup.png"/>
+          <p:cNvPr id="17411" name="Picture 17410" descr="scenario_b_tracking.png"/>
           <p:cNvPicPr>
             <a:picLocks noChangeAspect="1"/>
           </p:cNvPicPr>
@@ -6551,6 +6005,11 @@
         </p:spPr>
       </p:pic>
     </p:spTree>
+    <p:extLst>
+      <p:ext uri="{BB962C8B-B14F-4D97-AF65-F5344CB8AC3E}">
+        <p14:creationId xmlns:p14="http://schemas.microsoft.com/office/powerpoint/2010/main" val="3753387913"/>
+      </p:ext>
+    </p:extLst>
   </p:cSld>
   <p:clrMapOvr>
     <a:masterClrMapping/>
@@ -6563,7 +6022,13 @@
   <p:cSld>
     <p:spTree>
       <p:nvGrpSpPr>
-        <p:cNvPr id="1" name=""/>
+        <p:cNvPr id="1" name="">
+          <a:extLst>
+            <a:ext uri="{FF2B5EF4-FFF2-40B4-BE49-F238E27FC236}">
+              <a16:creationId xmlns:a16="http://schemas.microsoft.com/office/drawing/2014/main" id="{48B09052-50AE-B3C2-6A1C-5CFF37D94A7E}"/>
+            </a:ext>
+          </a:extLst>
+        </p:cNvPr>
         <p:cNvGrpSpPr/>
         <p:nvPr/>
       </p:nvGrpSpPr>
@@ -6577,7 +6042,13 @@
       </p:grpSpPr>
       <p:sp>
         <p:nvSpPr>
-          <p:cNvPr id="17409" name="Title 1"/>
+          <p:cNvPr id="17409" name="Title 1">
+            <a:extLst>
+              <a:ext uri="{FF2B5EF4-FFF2-40B4-BE49-F238E27FC236}">
+                <a16:creationId xmlns:a16="http://schemas.microsoft.com/office/drawing/2014/main" id="{5E03BF1A-7989-5C44-934B-D93E149184A6}"/>
+              </a:ext>
+            </a:extLst>
+          </p:cNvPr>
           <p:cNvSpPr>
             <a:spLocks noGrp="1"/>
           </p:cNvSpPr>
@@ -6598,14 +6069,20 @@
               </a:defRPr>
             </a:pPr>
             <a:r>
-              <a:t>FEASIBILITY, VIABILITY &amp; SAFETY</a:t>
-            </a:r>
-          </a:p>
-        </p:txBody>
-      </p:sp>
-      <p:sp>
-        <p:nvSpPr>
-          <p:cNvPr id="17410" name="TextBox 8"/>
+              <a:t>SIMULATION RESULTS &amp; ARTIFACTS</a:t>
+            </a:r>
+          </a:p>
+        </p:txBody>
+      </p:sp>
+      <p:sp>
+        <p:nvSpPr>
+          <p:cNvPr id="17410" name="TextBox 8">
+            <a:extLst>
+              <a:ext uri="{FF2B5EF4-FFF2-40B4-BE49-F238E27FC236}">
+                <a16:creationId xmlns:a16="http://schemas.microsoft.com/office/drawing/2014/main" id="{DD0C6F84-D6ED-416D-7179-055149D83FA6}"/>
+              </a:ext>
+            </a:extLst>
+          </p:cNvPr>
           <p:cNvSpPr txBox="1">
             <a:spLocks noChangeArrowheads="1"/>
           </p:cNvSpPr>
@@ -6656,34 +6133,20 @@
               </a:defRPr>
             </a:pPr>
             <a:r>
-              <a:t>Safety Envelope &amp; Feasibility Analysis</a:t>
-            </a:r>
-            <a:endParaRPr kumimoji="0" lang="en-US" sz="2800" b="0" i="0" u="none" strike="noStrike" kern="1200" cap="none" spc="0" normalizeH="0" baseline="0" noProof="0" dirty="0">
-              <a:ln>
-                <a:noFill/>
-              </a:ln>
-              <a:solidFill>
-                <a:prstClr val="black"/>
-              </a:solidFill>
-              <a:effectLst/>
-              <a:uLnTx/>
-              <a:uFillTx/>
-              <a:latin typeface="Arial" pitchFamily="34" charset="0"/>
-              <a:ea typeface="ＭＳ Ｐゴシック" pitchFamily="1" charset="-128"/>
-              <a:cs typeface="Arial" pitchFamily="34" charset="0"/>
-            </a:endParaRPr>
+              <a:t>Demonstrated Performance in Control Scenarios</a:t>
+            </a:r>
           </a:p>
           <a:p>
             <a:pPr>
               <a:spcAft>
                 <a:spcPts val="800"/>
               </a:spcAft>
-              <a:defRPr sz="1250">
+              <a:defRPr sz="1050">
                 <a:latin typeface="Arial"/>
               </a:defRPr>
             </a:pPr>
             <a:r>
-              <a:t>• Low Computational Cost: Evaluating 101 candidate trajectories takes &lt; 10 ms on standard industrial edge compute modules (e.g. Raspberry Pi, Siemens IOT2050, or DCS). No optimization solver library is required.</a:t>
+              <a:t>• Scenario A (Startup): Ramps choke at max 5%/hr, smoothly reaching 120 bbl/hr target with zero violations.</a:t>
             </a:r>
           </a:p>
           <a:p>
@@ -6691,12 +6154,12 @@
               <a:spcAft>
                 <a:spcPts val="800"/>
               </a:spcAft>
-              <a:defRPr sz="1250">
+              <a:defRPr sz="1050">
                 <a:latin typeface="Arial"/>
               </a:defRPr>
             </a:pPr>
             <a:r>
-              <a:t>• Process Safety Envelope: Safety constraints are verified over the prediction horizon Hp = 30h. Unsafe choke openings are blocked.</a:t>
+              <a:t>• Scenario B (Tracking): Setpoint steps to 150 bbl/hr. Controller regulates choke to 60.9% and tracks rate smoothly. Pressures remain safe (BHP = 2931 psi).</a:t>
             </a:r>
           </a:p>
           <a:p>
@@ -6704,12 +6167,12 @@
               <a:spcAft>
                 <a:spcPts val="800"/>
               </a:spcAft>
-              <a:defRPr sz="1250">
+              <a:defRPr sz="1050">
                 <a:latin typeface="Arial"/>
               </a:defRPr>
             </a:pPr>
             <a:r>
-              <a:t>• Process Noise Tolerance: Uses deterministic ARX equations for predictive models while successfully handling process noise (Q_sigma = 0.73, BHP_sigma = 2.91) in actual operations.</a:t>
+              <a:t>• Scenario C (Infeasible Target = 200 bbl/hr): Caps choke opening at 61.9% to maintain BHP &gt;= 2900 psi limit, settling at maximum safe flow rate of 151.7 bbl/hr.</a:t>
             </a:r>
           </a:p>
           <a:p>
@@ -6717,19 +6180,51 @@
               <a:spcAft>
                 <a:spcPts val="800"/>
               </a:spcAft>
-              <a:defRPr sz="1250">
+              <a:defRPr sz="1050">
                 <a:latin typeface="Arial"/>
               </a:defRPr>
             </a:pPr>
             <a:r>
-              <a:t>• Economic Value: Maximizes production by safely tracking target rate, or backing off to maximum safe rate when targets are infeasible.</a:t>
-            </a:r>
-          </a:p>
-        </p:txBody>
-      </p:sp>
-      <p:sp>
-        <p:nvSpPr>
-          <p:cNvPr id="6" name="Slide Number Placeholder 5"/>
+              <a:t>• Candidate Search Logging: Logs 101 candidate evaluations per hour showing Safe vs. Rejected moves (e.g., 'Evaluated: 101 | Safe: 51 | Rejected: 50') with physical rejection reasons.</a:t>
+            </a:r>
+          </a:p>
+          <a:p>
+            <a:pPr>
+              <a:spcAft>
+                <a:spcPts val="800"/>
+              </a:spcAft>
+              <a:defRPr sz="1050">
+                <a:latin typeface="Arial"/>
+              </a:defRPr>
+            </a:pPr>
+            <a:r>
+              <a:t>• Summary Analytics: Terminal prints a clear summary block detailing requested rate (200 bbl/hr), maximum safe production (151.7 bbl/hr), active limits (BHP, WHP), and safe boundary settlement.</a:t>
+            </a:r>
+          </a:p>
+          <a:p>
+            <a:pPr>
+              <a:spcAft>
+                <a:spcPts val="800"/>
+              </a:spcAft>
+              <a:defRPr sz="1050">
+                <a:latin typeface="Arial"/>
+              </a:defRPr>
+            </a:pPr>
+            <a:r>
+              <a:t>• DCS Streamlit Dashboard: Operates as a live operator screen supporting custom setpoints, horizon adjustments, constraint limits, and real-time trend plots.</a:t>
+            </a:r>
+          </a:p>
+        </p:txBody>
+      </p:sp>
+      <p:sp>
+        <p:nvSpPr>
+          <p:cNvPr id="6" name="Slide Number Placeholder 5">
+            <a:extLst>
+              <a:ext uri="{FF2B5EF4-FFF2-40B4-BE49-F238E27FC236}">
+                <a16:creationId xmlns:a16="http://schemas.microsoft.com/office/drawing/2014/main" id="{84B14AAA-63FC-5F17-FE74-5405495A1CD3}"/>
+              </a:ext>
+            </a:extLst>
+          </p:cNvPr>
           <p:cNvSpPr>
             <a:spLocks noGrp="1"/>
           </p:cNvSpPr>
@@ -6812,363 +6307,6 @@
       </p:sp>
       <p:sp>
         <p:nvSpPr>
-          <p:cNvPr id="7" name="Footer Placeholder 6"/>
-          <p:cNvSpPr>
-            <a:spLocks noGrp="1"/>
-          </p:cNvSpPr>
-          <p:nvPr>
-            <p:ph type="ftr" sz="quarter" idx="11"/>
-          </p:nvPr>
-        </p:nvSpPr>
-        <p:spPr>
-          <a:xfrm>
-            <a:off x="4648200" y="6356353"/>
-            <a:ext cx="3204000" cy="365125"/>
-          </a:xfrm>
-        </p:spPr>
-        <p:txBody>
-          <a:bodyPr/>
-          <a:lstStyle/>
-          <a:p>
-            <a:pPr marL="0" marR="0" lvl="0" indent="0" algn="ctr" defTabSz="457200" rtl="0" eaLnBrk="1" fontAlgn="auto" latinLnBrk="0" hangingPunct="1">
-              <a:lnSpc>
-                <a:spcPct val="100000"/>
-              </a:lnSpc>
-              <a:spcBef>
-                <a:spcPts val="0"/>
-              </a:spcBef>
-              <a:spcAft>
-                <a:spcPts val="0"/>
-              </a:spcAft>
-              <a:buClrTx/>
-              <a:buSzTx/>
-              <a:buFontTx/>
-              <a:buNone/>
-              <a:tabLst/>
-              <a:defRPr/>
-            </a:pPr>
-            <a:r>
-              <a:rPr kumimoji="0" lang="en-US" sz="1200" b="0" i="0" u="none" strike="noStrike" kern="1200" cap="none" spc="0" normalizeH="0" baseline="0" noProof="0">
-                <a:ln>
-                  <a:noFill/>
-                </a:ln>
-                <a:solidFill>
-                  <a:prstClr val="white"/>
-                </a:solidFill>
-                <a:effectLst/>
-                <a:uLnTx/>
-                <a:uFillTx/>
-                <a:latin typeface="TradeGothic"/>
-                <a:ea typeface="+mn-ea"/>
-                <a:cs typeface="+mn-cs"/>
-              </a:rPr>
-              <a:t>@SIH Idea submission- Template</a:t>
-            </a:r>
-            <a:endParaRPr kumimoji="0" lang="en-US" sz="1200" b="0" i="0" u="none" strike="noStrike" kern="1200" cap="none" spc="0" normalizeH="0" baseline="0" noProof="0" dirty="0">
-              <a:ln>
-                <a:noFill/>
-              </a:ln>
-              <a:solidFill>
-                <a:prstClr val="white"/>
-              </a:solidFill>
-              <a:effectLst/>
-              <a:uLnTx/>
-              <a:uFillTx/>
-              <a:latin typeface="TradeGothic"/>
-              <a:ea typeface="+mn-ea"/>
-              <a:cs typeface="+mn-cs"/>
-            </a:endParaRPr>
-          </a:p>
-        </p:txBody>
-      </p:sp>
-      <p:pic>
-        <p:nvPicPr>
-          <p:cNvPr id="17411" name="Picture 17410" descr="scenario_b_tracking.png"/>
-          <p:cNvPicPr>
-            <a:picLocks noChangeAspect="1"/>
-          </p:cNvPicPr>
-          <p:nvPr/>
-        </p:nvPicPr>
-        <p:blipFill>
-          <a:blip r:embed="rId3"/>
-          <a:stretch>
-            <a:fillRect/>
-          </a:stretch>
-        </p:blipFill>
-        <p:spPr>
-          <a:xfrm>
-            <a:off x="6217920" y="1371600"/>
-            <a:ext cx="5486400" cy="4389120"/>
-          </a:xfrm>
-          <a:prstGeom prst="rect">
-            <a:avLst/>
-          </a:prstGeom>
-        </p:spPr>
-      </p:pic>
-    </p:spTree>
-    <p:extLst>
-      <p:ext uri="{BB962C8B-B14F-4D97-AF65-F5344CB8AC3E}">
-        <p14:creationId xmlns:p14="http://schemas.microsoft.com/office/powerpoint/2010/main" val="3753387913"/>
-      </p:ext>
-    </p:extLst>
-  </p:cSld>
-  <p:clrMapOvr>
-    <a:masterClrMapping/>
-  </p:clrMapOvr>
-</p:sld>
-</file>
-
-<file path=ppt/slides/slide6.xml><?xml version="1.0" encoding="utf-8"?>
-<p:sld xmlns:a="http://schemas.openxmlformats.org/drawingml/2006/main" xmlns:r="http://schemas.openxmlformats.org/officeDocument/2006/relationships" xmlns:p="http://schemas.openxmlformats.org/presentationml/2006/main">
-  <p:cSld>
-    <p:spTree>
-      <p:nvGrpSpPr>
-        <p:cNvPr id="1" name="">
-          <a:extLst>
-            <a:ext uri="{FF2B5EF4-FFF2-40B4-BE49-F238E27FC236}">
-              <a16:creationId xmlns:a16="http://schemas.microsoft.com/office/drawing/2014/main" id="{48B09052-50AE-B3C2-6A1C-5CFF37D94A7E}"/>
-            </a:ext>
-          </a:extLst>
-        </p:cNvPr>
-        <p:cNvGrpSpPr/>
-        <p:nvPr/>
-      </p:nvGrpSpPr>
-      <p:grpSpPr>
-        <a:xfrm>
-          <a:off x="0" y="0"/>
-          <a:ext cx="0" cy="0"/>
-          <a:chOff x="0" y="0"/>
-          <a:chExt cx="0" cy="0"/>
-        </a:xfrm>
-      </p:grpSpPr>
-      <p:sp>
-        <p:nvSpPr>
-          <p:cNvPr id="17409" name="Title 1">
-            <a:extLst>
-              <a:ext uri="{FF2B5EF4-FFF2-40B4-BE49-F238E27FC236}">
-                <a16:creationId xmlns:a16="http://schemas.microsoft.com/office/drawing/2014/main" id="{5E03BF1A-7989-5C44-934B-D93E149184A6}"/>
-              </a:ext>
-            </a:extLst>
-          </p:cNvPr>
-          <p:cNvSpPr>
-            <a:spLocks noGrp="1"/>
-          </p:cNvSpPr>
-          <p:nvPr>
-            <p:ph type="title"/>
-          </p:nvPr>
-        </p:nvSpPr>
-        <p:spPr/>
-        <p:txBody>
-          <a:bodyPr/>
-          <a:lstStyle/>
-          <a:p>
-            <a:pPr>
-              <a:defRPr b="1">
-                <a:solidFill>
-                  <a:srgbClr val="1D4ED8"/>
-                </a:solidFill>
-              </a:defRPr>
-            </a:pPr>
-            <a:r>
-              <a:t>SIMULATION RESULTS &amp; ARTIFACTS</a:t>
-            </a:r>
-          </a:p>
-        </p:txBody>
-      </p:sp>
-      <p:sp>
-        <p:nvSpPr>
-          <p:cNvPr id="17410" name="TextBox 8">
-            <a:extLst>
-              <a:ext uri="{FF2B5EF4-FFF2-40B4-BE49-F238E27FC236}">
-                <a16:creationId xmlns:a16="http://schemas.microsoft.com/office/drawing/2014/main" id="{DD0C6F84-D6ED-416D-7179-055149D83FA6}"/>
-              </a:ext>
-            </a:extLst>
-          </p:cNvPr>
-          <p:cNvSpPr txBox="1">
-            <a:spLocks noChangeArrowheads="1"/>
-          </p:cNvSpPr>
-          <p:nvPr/>
-        </p:nvSpPr>
-        <p:spPr bwMode="auto">
-          <a:xfrm>
-            <a:off x="457200" y="1371600"/>
-            <a:ext cx="5486400" cy="4754880"/>
-          </a:xfrm>
-          <a:prstGeom prst="rect">
-            <a:avLst/>
-          </a:prstGeom>
-          <a:noFill/>
-          <a:ln w="9525">
-            <a:noFill/>
-            <a:miter lim="800000"/>
-            <a:headEnd/>
-            <a:tailEnd/>
-          </a:ln>
-        </p:spPr>
-        <p:txBody>
-          <a:bodyPr wrap="square">
-            <a:spAutoFit/>
-          </a:bodyPr>
-          <a:lstStyle/>
-          <a:p>
-            <a:pPr marL="342900" marR="0" lvl="0" indent="-342900" algn="just" defTabSz="457200" rtl="0" eaLnBrk="1" fontAlgn="base" latinLnBrk="0" hangingPunct="1">
-              <a:lnSpc>
-                <a:spcPct val="100000"/>
-              </a:lnSpc>
-              <a:spcBef>
-                <a:spcPct val="0"/>
-              </a:spcBef>
-              <a:spcAft>
-                <a:spcPts val="1200"/>
-              </a:spcAft>
-              <a:buClrTx/>
-              <a:buSzTx/>
-              <a:buFont typeface="Arial" panose="020B0604020202020204" pitchFamily="34" charset="0"/>
-              <a:buChar char="•"/>
-              <a:tabLst/>
-              <a:defRPr sz="1800" b="1">
-                <a:solidFill>
-                  <a:srgbClr val="1E293B"/>
-                </a:solidFill>
-                <a:latin typeface="Arial"/>
-              </a:defRPr>
-            </a:pPr>
-            <a:r>
-              <a:t>Demonstrated Performance in Control Scenarios</a:t>
-            </a:r>
-          </a:p>
-          <a:p>
-            <a:pPr>
-              <a:spcAft>
-                <a:spcPts val="800"/>
-              </a:spcAft>
-              <a:defRPr sz="1200">
-                <a:latin typeface="Arial"/>
-              </a:defRPr>
-            </a:pPr>
-            <a:r>
-              <a:t>• Scenario A (Startup to Target): Well moves smoothly from 90 bbl/hr (30% choke) to 120 bbl/hr. Choke ramps at max rate of 5%/hr, stabilizing with zero pressure violations.</a:t>
-            </a:r>
-          </a:p>
-          <a:p>
-            <a:pPr>
-              <a:spcAft>
-                <a:spcPts val="800"/>
-              </a:spcAft>
-              <a:defRPr sz="1200">
-                <a:latin typeface="Arial"/>
-              </a:defRPr>
-            </a:pPr>
-            <a:r>
-              <a:t>• Scenario B (Target Tracking): Target steps from 100 to 150 bbl/hr. Controller adjusts choke to 60.9% and tracks the new rate smoothly. Pressures remain safe (min BHP = 2916.5 psi vs limit of 2900 psi).</a:t>
-            </a:r>
-          </a:p>
-          <a:p>
-            <a:pPr>
-              <a:spcAft>
-                <a:spcPts val="800"/>
-              </a:spcAft>
-              <a:defRPr sz="1200">
-                <a:latin typeface="Arial"/>
-              </a:defRPr>
-            </a:pPr>
-            <a:r>
-              <a:t>• Scenario C (Infeasible Target): Target steps to 160 bbl/hr. The controller automatically restricts choke opening to 61.8% to maintain BHP &gt;= 2900 psi, settling at the maximum safe flow rate of 153.6 bbl/hr (with noise).</a:t>
-            </a:r>
-          </a:p>
-        </p:txBody>
-      </p:sp>
-      <p:sp>
-        <p:nvSpPr>
-          <p:cNvPr id="6" name="Slide Number Placeholder 5">
-            <a:extLst>
-              <a:ext uri="{FF2B5EF4-FFF2-40B4-BE49-F238E27FC236}">
-                <a16:creationId xmlns:a16="http://schemas.microsoft.com/office/drawing/2014/main" id="{84B14AAA-63FC-5F17-FE74-5405495A1CD3}"/>
-              </a:ext>
-            </a:extLst>
-          </p:cNvPr>
-          <p:cNvSpPr>
-            <a:spLocks noGrp="1"/>
-          </p:cNvSpPr>
-          <p:nvPr>
-            <p:ph type="sldNum" sz="quarter" idx="12"/>
-          </p:nvPr>
-        </p:nvSpPr>
-        <p:spPr/>
-        <p:txBody>
-          <a:bodyPr/>
-          <a:lstStyle/>
-          <a:p>
-            <a:pPr marL="0" marR="0" lvl="0" indent="0" algn="r" defTabSz="457200" rtl="0" eaLnBrk="1" fontAlgn="base" latinLnBrk="0" hangingPunct="1">
-              <a:lnSpc>
-                <a:spcPct val="100000"/>
-              </a:lnSpc>
-              <a:spcBef>
-                <a:spcPct val="0"/>
-              </a:spcBef>
-              <a:spcAft>
-                <a:spcPct val="0"/>
-              </a:spcAft>
-              <a:buClrTx/>
-              <a:buSzTx/>
-              <a:buFontTx/>
-              <a:buNone/>
-              <a:tabLst/>
-              <a:defRPr/>
-            </a:pPr>
-            <a:fld id="{677C3CE7-23F7-4828-823C-E0205DF2CF97}" type="slidenum">
-              <a:rPr kumimoji="0" lang="en-US" sz="1200" b="1" i="0" u="none" strike="noStrike" kern="1200" cap="none" spc="0" normalizeH="0" baseline="0" noProof="0">
-                <a:ln>
-                  <a:noFill/>
-                </a:ln>
-                <a:solidFill>
-                  <a:prstClr val="white"/>
-                </a:solidFill>
-                <a:effectLst/>
-                <a:uLnTx/>
-                <a:uFillTx/>
-                <a:latin typeface="TradeGothic" pitchFamily="1" charset="0"/>
-                <a:ea typeface="ＭＳ Ｐゴシック" pitchFamily="1" charset="-128"/>
-                <a:cs typeface="+mn-cs"/>
-              </a:rPr>
-              <a:pPr marL="0" marR="0" lvl="0" indent="0" algn="r" defTabSz="457200" rtl="0" eaLnBrk="1" fontAlgn="base" latinLnBrk="0" hangingPunct="1">
-                <a:lnSpc>
-                  <a:spcPct val="100000"/>
-                </a:lnSpc>
-                <a:spcBef>
-                  <a:spcPct val="0"/>
-                </a:spcBef>
-                <a:spcAft>
-                  <a:spcPct val="0"/>
-                </a:spcAft>
-                <a:buClrTx/>
-                <a:buSzTx/>
-                <a:buFontTx/>
-                <a:buNone/>
-                <a:tabLst/>
-                <a:defRPr/>
-              </a:pPr>
-              <a:t>6</a:t>
-            </a:fld>
-            <a:endParaRPr kumimoji="0" lang="en-US" sz="1200" b="1" i="0" u="none" strike="noStrike" kern="1200" cap="none" spc="0" normalizeH="0" baseline="0" noProof="0" dirty="0">
-              <a:ln>
-                <a:noFill/>
-              </a:ln>
-              <a:solidFill>
-                <a:prstClr val="white"/>
-              </a:solidFill>
-              <a:effectLst/>
-              <a:uLnTx/>
-              <a:uFillTx/>
-              <a:latin typeface="TradeGothic" pitchFamily="1" charset="0"/>
-              <a:ea typeface="ＭＳ Ｐゴシック" pitchFamily="1" charset="-128"/>
-              <a:cs typeface="+mn-cs"/>
-            </a:endParaRPr>
-          </a:p>
-        </p:txBody>
-      </p:sp>
-      <p:sp>
-        <p:nvSpPr>
           <p:cNvPr id="7" name="Footer Placeholder 6">
             <a:extLst>
               <a:ext uri="{FF2B5EF4-FFF2-40B4-BE49-F238E27FC236}">
@@ -7281,7 +6419,7 @@
 </p:sld>
 </file>
 
-<file path=ppt/slides/slide7.xml><?xml version="1.0" encoding="utf-8"?>
+<file path=ppt/slides/slide6.xml><?xml version="1.0" encoding="utf-8"?>
 <p:sld xmlns:a="http://schemas.openxmlformats.org/drawingml/2006/main" xmlns:r="http://schemas.openxmlformats.org/officeDocument/2006/relationships" xmlns:p="http://schemas.openxmlformats.org/presentationml/2006/main">
   <p:cSld>
     <p:spTree>
@@ -7337,7 +6475,7 @@
         <p:spPr bwMode="auto">
           <a:xfrm>
             <a:off x="457200" y="1371600"/>
-            <a:ext cx="11274552" cy="4754880"/>
+            <a:ext cx="11274552" cy="2657138"/>
           </a:xfrm>
           <a:prstGeom prst="rect">
             <a:avLst/>
@@ -7379,6 +6517,7 @@
               </a:defRPr>
             </a:pPr>
             <a:r>
+              <a:rPr dirty="0"/>
               <a:t>Academic &amp; Industrial References</a:t>
             </a:r>
             <a:endParaRPr kumimoji="0" lang="en-US" sz="2800" b="0" i="0" u="none" strike="noStrike" kern="1200" cap="none" spc="0" normalizeH="0" baseline="0" noProof="0" dirty="0">
@@ -7401,65 +6540,148 @@
               <a:spcAft>
                 <a:spcPts val="800"/>
               </a:spcAft>
-              <a:defRPr sz="1400">
+              <a:defRPr sz="1100">
                 <a:latin typeface="Arial"/>
               </a:defRPr>
             </a:pPr>
             <a:r>
+              <a:rPr dirty="0"/>
               <a:t>[1] Camacho, E. F. and Alba, C. B. 'Model Predictive Control', 2nd Edition, Springer-Verlag, 2013.</a:t>
             </a:r>
+            <a:br>
+              <a:rPr dirty="0"/>
+            </a:br>
+            <a:r>
+              <a:rPr dirty="0"/>
+              <a:t>    URL: </a:t>
+            </a:r>
+            <a:r>
+              <a:rPr dirty="0">
+                <a:hlinkClick r:id="rId3"/>
+              </a:rPr>
+              <a:t>https://link.springer.com/book/10.1007/978-3-642-18189-4</a:t>
+            </a:r>
+            <a:endParaRPr dirty="0"/>
           </a:p>
           <a:p>
             <a:pPr>
               <a:spcAft>
                 <a:spcPts val="800"/>
               </a:spcAft>
-              <a:defRPr sz="1400">
+              <a:defRPr sz="1100">
                 <a:latin typeface="Arial"/>
               </a:defRPr>
             </a:pPr>
             <a:r>
+              <a:rPr dirty="0"/>
               <a:t>[2] Economides, M. J., Hill, A. D. and Ehlig-Economides, C. 'Petroleum Production Systems', Prentice Hall, 2012.</a:t>
             </a:r>
+            <a:br>
+              <a:rPr dirty="0"/>
+            </a:br>
+            <a:r>
+              <a:rPr dirty="0"/>
+              <a:t>    URL: </a:t>
+            </a:r>
+            <a:r>
+              <a:rPr dirty="0">
+                <a:hlinkClick r:id="rId4"/>
+              </a:rPr>
+              <a:t>https://www.pearson.com/en-us/subject-catalog/p/petroleum-production-systems/P200000003290</a:t>
+            </a:r>
+            <a:endParaRPr dirty="0"/>
           </a:p>
           <a:p>
             <a:pPr>
               <a:spcAft>
                 <a:spcPts val="800"/>
               </a:spcAft>
-              <a:defRPr sz="1400">
+              <a:defRPr sz="1100">
                 <a:latin typeface="Arial"/>
               </a:defRPr>
             </a:pPr>
             <a:r>
+              <a:rPr dirty="0"/>
               <a:t>[3] Golan, M. and Whitson, C. H. 'Well Performance', 2nd Edition, Prentice Hall, 1991.</a:t>
             </a:r>
+            <a:br>
+              <a:rPr dirty="0"/>
+            </a:br>
+            <a:r>
+              <a:rPr dirty="0"/>
+              <a:t>    URL: </a:t>
+            </a:r>
+            <a:r>
+              <a:rPr dirty="0">
+                <a:hlinkClick r:id="rId5"/>
+              </a:rPr>
+              <a:t>https://www.onepetro.org/books/SPE/Well-Performance</a:t>
+            </a:r>
+            <a:endParaRPr dirty="0"/>
           </a:p>
           <a:p>
             <a:pPr>
               <a:spcAft>
                 <a:spcPts val="800"/>
               </a:spcAft>
-              <a:defRPr sz="1400">
+              <a:defRPr sz="1100">
                 <a:latin typeface="Arial"/>
               </a:defRPr>
             </a:pPr>
             <a:r>
+              <a:rPr dirty="0"/>
               <a:t>[4] Foss, B., Grimstad, B., Shakerian, M. and Sureshkumar, K. 'Control structure design for oil fields - a case study', Journal of Process Control, Vol. 68, pp. 112-124, 2018.</a:t>
             </a:r>
+            <a:br>
+              <a:rPr dirty="0"/>
+            </a:br>
+            <a:r>
+              <a:rPr dirty="0"/>
+              <a:t>    URL: </a:t>
+            </a:r>
+            <a:r>
+              <a:rPr dirty="0">
+                <a:hlinkClick r:id="rId6"/>
+              </a:rPr>
+              <a:t>https://doi.org/10.1016/j.jprocont.2018.05.006</a:t>
+            </a:r>
+            <a:endParaRPr dirty="0"/>
           </a:p>
           <a:p>
             <a:pPr>
               <a:spcAft>
                 <a:spcPts val="800"/>
               </a:spcAft>
-              <a:defRPr sz="1400">
+              <a:defRPr sz="1100">
                 <a:latin typeface="Arial"/>
               </a:defRPr>
             </a:pPr>
             <a:r>
-              <a:t>[5] Shinskey, F. G. 'Process Control Systems: Application, Design, and Adjustment', McGraw-Hill, 1996.</a:t>
-            </a:r>
+              <a:rPr dirty="0"/>
+              <a:t>[5] </a:t>
+            </a:r>
+            <a:r>
+              <a:rPr dirty="0" err="1"/>
+              <a:t>Shinskey</a:t>
+            </a:r>
+            <a:r>
+              <a:rPr dirty="0"/>
+              <a:t>, F. G. 'Process Control Systems: Application, Design, and Adjustment', McGraw-Hill, 1996.</a:t>
+            </a:r>
+            <a:br>
+              <a:rPr dirty="0"/>
+            </a:br>
+            <a:r>
+              <a:rPr dirty="0"/>
+              <a:t>    URL: </a:t>
+            </a:r>
+            <a:r>
+              <a:rPr dirty="0">
+                <a:hlinkClick r:id="rId7"/>
+              </a:rPr>
+              <a:t>https://www.accessengineeringlibrary.com/content/book/9780070571013</a:t>
+            </a:r>
+            <a:endParaRPr dirty="0"/>
           </a:p>
         </p:txBody>
       </p:sp>
@@ -7527,7 +6749,7 @@
                 <a:tabLst/>
                 <a:defRPr/>
               </a:pPr>
-              <a:t>7</a:t>
+              <a:t>6</a:t>
             </a:fld>
             <a:endParaRPr kumimoji="0" lang="en-US" sz="1200" b="1" i="0" u="none" strike="noStrike" kern="1200" cap="none" spc="0" normalizeH="0" baseline="0" noProof="0" dirty="0">
               <a:ln>

</xml_diff>